<commit_message>
L3: correggere una cella a mano
Passo nel task (IMP0253, condizione doppia con &), slide e dispensa.

Co-Authored-By: Claude Opus 5.5 <noreply@anthropic.com>
Claude-Session: https://claude.ai/code/session_014CzWDFXvYNxqLeD99LSN3G
</commit_message>
<xml_diff>
--- a/lezioni/L03_pulizia/slide.pptx
+++ b/lezioni/L03_pulizia/slide.pptx
@@ -14,9 +14,10 @@
     <p:sldId id="262" r:id="rId8"/>
     <p:sldId id="263" r:id="rId9"/>
     <p:sldId id="264" r:id="rId10"/>
+    <p:sldId id="265" r:id="rId11"/>
   </p:sldIdLst>
   <p:notesMasterIdLst>
-    <p:notesMasterId r:id="rId11"/>
+    <p:notesMasterId r:id="rId12"/>
   </p:notesMasterIdLst>
   <p:sldSz cx="12192000" cy="6858000"/>
   <p:notesSz cx="6858000" cy="12192000"/>
@@ -115,29 +116,30 @@
   <p:extLst>
     <p:ext uri="{521415D9-36F7-43E2-AB2F-B90AF26B5E84}">
       <p14:sectionLst xmlns:p14="http://schemas.microsoft.com/office/powerpoint/2010/main">
-        <p14:section name="Apertura" id="{1dae2e08-afdd-a82a-6205-071f6aef4fca}">
+        <p14:section name="Apertura" id="{b4cfa0a0-58e7-7efc-7644-5ed1553c8581}">
           <p14:sldIdLst>
             <p14:sldId id="256"/>
             <p14:sldId id="257"/>
           </p14:sldIdLst>
         </p14:section>
-        <p14:section name="Spiegazione" id="{728e10d7-81ad-602e-a2a1-4d5610677c0d}">
+        <p14:section name="Spiegazione" id="{fe60a480-783b-3f9e-960c-847513db0732}">
           <p14:sldIdLst>
             <p14:sldId id="258"/>
             <p14:sldId id="259"/>
             <p14:sldId id="260"/>
             <p14:sldId id="261"/>
             <p14:sldId id="262"/>
-          </p14:sldIdLst>
-        </p14:section>
-        <p14:section name="Task" id="{1d774037-3726-77e3-d854-daf778df96df}">
-          <p14:sldIdLst>
             <p14:sldId id="263"/>
           </p14:sldIdLst>
         </p14:section>
-        <p14:section name="Chiusura" id="{62294d44-517d-8d2b-89b7-70fe5a733126}">
+        <p14:section name="Task" id="{fa147481-25f1-b82c-ce81-da24abb09dce}">
           <p14:sldIdLst>
             <p14:sldId id="264"/>
+          </p14:sldIdLst>
+        </p14:section>
+        <p14:section name="Chiusura" id="{3392d9f0-a8c3-aa7b-2713-24e68fab6142}">
+          <p14:sldIdLst>
+            <p14:sldId id="265"/>
           </p14:sldIdLst>
         </p14:section>
       </p14:sectionLst>
@@ -586,6 +588,94 @@
 </p:notes>
 </file>
 
+<file path=ppt/notesSlides/notesSlide10.xml><?xml version="1.0" encoding="utf-8"?>
+<p:notes xmlns:a="http://schemas.openxmlformats.org/drawingml/2006/main" xmlns:r="http://schemas.openxmlformats.org/officeDocument/2006/relationships" xmlns:p="http://schemas.openxmlformats.org/presentationml/2006/main">
+  <p:cSld>
+    <p:spTree>
+      <p:nvGrpSpPr>
+        <p:cNvPr id="1" name=""/>
+        <p:cNvGrpSpPr/>
+        <p:nvPr/>
+      </p:nvGrpSpPr>
+      <p:grpSpPr>
+        <a:xfrm>
+          <a:off x="0" y="0"/>
+          <a:ext cx="0" cy="0"/>
+          <a:chOff x="0" y="0"/>
+          <a:chExt cx="0" cy="0"/>
+        </a:xfrm>
+      </p:grpSpPr>
+      <p:sp>
+        <p:nvSpPr>
+          <p:cNvPr id="2" name="Slide Image Placeholder 1"/>
+          <p:cNvSpPr>
+            <a:spLocks noGrp="1" noRot="1" noChangeAspect="1"/>
+          </p:cNvSpPr>
+          <p:nvPr>
+            <p:ph type="sldImg"/>
+          </p:nvPr>
+        </p:nvSpPr>
+        <p:spPr/>
+      </p:sp>
+      <p:sp>
+        <p:nvSpPr>
+          <p:cNvPr id="3" name="Notes Placeholder 2"/>
+          <p:cNvSpPr>
+            <a:spLocks noGrp="1"/>
+          </p:cNvSpPr>
+          <p:nvPr>
+            <p:ph type="body" idx="1"/>
+          </p:nvPr>
+        </p:nvSpPr>
+        <p:spPr/>
+        <p:txBody>
+          <a:bodyPr/>
+          <a:lstStyle/>
+          <a:p>
+            <a:r>
+              <a:rPr lang="en-US" dirty="0"/>
+              <a:t/>
+            </a:r>
+            <a:endParaRPr lang="en-US" dirty="0"/>
+          </a:p>
+        </p:txBody>
+      </p:sp>
+      <p:sp>
+        <p:nvSpPr>
+          <p:cNvPr id="4" name="Slide Number Placeholder 3"/>
+          <p:cNvSpPr>
+            <a:spLocks noGrp="1"/>
+          </p:cNvSpPr>
+          <p:nvPr>
+            <p:ph type="sldNum" sz="quarter" idx="10"/>
+          </p:nvPr>
+        </p:nvSpPr>
+        <p:spPr/>
+        <p:txBody>
+          <a:bodyPr/>
+          <a:lstStyle/>
+          <a:p>
+            <a:fld id="{F7021451-1387-4CA6-816F-3879F97B5CBC}" type="slidenum">
+              <a:rPr lang="en-US"/>
+              <a:t>10</a:t>
+            </a:fld>
+            <a:endParaRPr lang="en-US"/>
+          </a:p>
+        </p:txBody>
+      </p:sp>
+    </p:spTree>
+    <p:extLst>
+      <p:ext uri="{BB962C8B-B14F-4D97-AF65-F5344CB8AC3E}">
+        <p14:creationId xmlns:p14="http://schemas.microsoft.com/office/powerpoint/2010/main" val="1024086991"/>
+      </p:ext>
+    </p:extLst>
+  </p:cSld>
+  <p:clrMapOvr>
+    <a:masterClrMapping/>
+  </p:clrMapOvr>
+</p:notes>
+</file>
+
 <file path=ppt/notesSlides/notesSlide2.xml><?xml version="1.0" encoding="utf-8"?>
 <p:notes xmlns:a="http://schemas.openxmlformats.org/drawingml/2006/main" xmlns:r="http://schemas.openxmlformats.org/officeDocument/2006/relationships" xmlns:p="http://schemas.openxmlformats.org/presentationml/2006/main">
   <p:cSld>
@@ -1160,7 +1250,7 @@
           <a:p>
             <a:r>
               <a:rPr lang="en-US" dirty="0"/>
-              <a:t>Girando tra i banchi: tenere d'occhio il passo 5. Chi trova più di 50 mancanti ha sbagliato l'ordine delle sostituzioni: non dirglielo, chiedergli se il numero torna.</a:t>
+              <a:t>L'esempio usa un dataset inventato (clienti e ordini) per non anticipare il task. Insistere sul controllo riga.sum() == 1 prima di modificare: se dà 0 la condizione è sbagliata, se dà più di 1 stai per cambiare più celle.</a:t>
             </a:r>
             <a:endParaRPr lang="en-US" dirty="0"/>
           </a:p>
@@ -1248,7 +1338,7 @@
           <a:p>
             <a:r>
               <a:rPr lang="en-US" dirty="0"/>
-              <a:t/>
+              <a:t>Girando tra i banchi: tenere d'occhio il passo 5. Chi trova più di 50 mancanti ha sbagliato l'ordine delle sostituzioni: non dirglielo, chiedergli se il numero torna.</a:t>
             </a:r>
             <a:endParaRPr lang="en-US" dirty="0"/>
           </a:p>
@@ -2118,6 +2208,107 @@
 </p:sld>
 </file>
 
+<file path=ppt/slides/slide10.xml><?xml version="1.0" encoding="utf-8"?>
+<p:sld xmlns:a="http://schemas.openxmlformats.org/drawingml/2006/main" xmlns:r="http://schemas.openxmlformats.org/officeDocument/2006/relationships" xmlns:p="http://schemas.openxmlformats.org/presentationml/2006/main">
+  <p:cSld name="Slide 10">
+    <p:spTree>
+      <p:nvGrpSpPr>
+        <p:cNvPr id="1" name=""/>
+        <p:cNvGrpSpPr/>
+        <p:nvPr/>
+      </p:nvGrpSpPr>
+      <p:grpSpPr>
+        <a:xfrm>
+          <a:off x="0" y="0"/>
+          <a:ext cx="0" cy="0"/>
+          <a:chOff x="0" y="0"/>
+          <a:chExt cx="0" cy="0"/>
+        </a:xfrm>
+      </p:grpSpPr>
+      <p:sp>
+        <p:nvSpPr>
+          <p:cNvPr id="2" name="Text 0"/>
+          <p:cNvSpPr/>
+          <p:nvPr>
+            <p:ph idx="100" type="title" hasCustomPrompt="1"/>
+          </p:nvPr>
+        </p:nvSpPr>
+        <p:spPr>
+          <a:xfrm>
+            <a:off x="731520" y="2103120"/>
+            <a:ext cx="10698480" cy="1463040"/>
+          </a:xfrm>
+          <a:prstGeom prst="rect">
+            <a:avLst/>
+          </a:prstGeom>
+          <a:noFill/>
+          <a:ln/>
+        </p:spPr>
+        <p:txBody>
+          <a:bodyPr wrap="square" lIns="0" tIns="0" rIns="0" bIns="0" rtlCol="0" anchor="b"/>
+          <a:lstStyle/>
+          <a:p>
+            <a:pPr algn="l" indent="0" marL="0">
+              <a:buNone/>
+            </a:pPr>
+            <a:r>
+              <a:rPr lang="en-US" sz="4800" b="1" dirty="0">
+                <a:solidFill>
+                  <a:srgbClr val="FFFFFF"/>
+                </a:solidFill>
+              </a:rPr>
+              <a:t>Prossima volta: raggruppare e disegnare</a:t>
+            </a:r>
+            <a:endParaRPr lang="en-US" sz="4800" dirty="0"/>
+          </a:p>
+        </p:txBody>
+      </p:sp>
+      <p:sp>
+        <p:nvSpPr>
+          <p:cNvPr id="3" name="Text 0"/>
+          <p:cNvSpPr/>
+          <p:nvPr>
+            <p:ph idx="101" type="body" hasCustomPrompt="1"/>
+          </p:nvPr>
+        </p:nvSpPr>
+        <p:spPr>
+          <a:xfrm>
+            <a:off x="731520" y="3749040"/>
+            <a:ext cx="10698480" cy="914400"/>
+          </a:xfrm>
+          <a:prstGeom prst="rect">
+            <a:avLst/>
+          </a:prstGeom>
+          <a:noFill/>
+          <a:ln/>
+        </p:spPr>
+        <p:txBody>
+          <a:bodyPr wrap="square" lIns="0" tIns="0" rIns="0" bIns="0" rtlCol="0" anchor="t"/>
+          <a:lstStyle/>
+          <a:p>
+            <a:pPr indent="0" marL="0">
+              <a:buNone/>
+            </a:pPr>
+            <a:r>
+              <a:rPr lang="en-US" sz="2200" dirty="0">
+                <a:solidFill>
+                  <a:srgbClr val="F4C06E"/>
+                </a:solidFill>
+              </a:rPr>
+              <a:t>Compito: Kaggle Learn – Pandas, «Data Types and Missing Values» (~20 min)</a:t>
+            </a:r>
+            <a:endParaRPr lang="en-US" sz="2200" dirty="0"/>
+          </a:p>
+        </p:txBody>
+      </p:sp>
+    </p:spTree>
+  </p:cSld>
+  <p:clrMapOvr>
+    <a:masterClrMapping/>
+  </p:clrMapOvr>
+</p:sld>
+</file>
+
 <file path=ppt/slides/slide2.xml><?xml version="1.0" encoding="utf-8"?>
 <p:sld xmlns:a="http://schemas.openxmlformats.org/drawingml/2006/main" xmlns:r="http://schemas.openxmlformats.org/officeDocument/2006/relationships" xmlns:p="http://schemas.openxmlformats.org/presentationml/2006/main">
   <p:cSld name="Slide 2">
@@ -5393,83 +5584,668 @@
         </p:nvSpPr>
         <p:spPr>
           <a:xfrm>
-            <a:off x="731520" y="2194560"/>
-            <a:ext cx="10698480" cy="1280160"/>
-          </a:xfrm>
-          <a:prstGeom prst="rect">
-            <a:avLst/>
-          </a:prstGeom>
-          <a:noFill/>
-          <a:ln/>
-        </p:spPr>
-        <p:txBody>
-          <a:bodyPr wrap="square" lIns="0" tIns="0" rIns="0" bIns="0" rtlCol="0" anchor="b"/>
+            <a:off x="548640" y="365760"/>
+            <a:ext cx="11064240" cy="822960"/>
+          </a:xfrm>
+          <a:prstGeom prst="rect">
+            <a:avLst/>
+          </a:prstGeom>
+          <a:noFill/>
+          <a:ln/>
+        </p:spPr>
+        <p:txBody>
+          <a:bodyPr wrap="square" lIns="0" tIns="0" rIns="0" bIns="0" rtlCol="0" anchor="ctr"/>
           <a:lstStyle/>
           <a:p>
             <a:pPr algn="l" indent="0" marL="0">
               <a:buNone/>
             </a:pPr>
             <a:r>
-              <a:rPr lang="en-US" sz="5400" b="1" dirty="0">
+              <a:rPr lang="en-US" sz="3600" b="1" dirty="0">
+                <a:solidFill>
+                  <a:srgbClr val="0F4C5C"/>
+                </a:solidFill>
+              </a:rPr>
+              <a:t>Correggere una cella a mano</a:t>
+            </a:r>
+            <a:endParaRPr lang="en-US" sz="3600" dirty="0"/>
+          </a:p>
+        </p:txBody>
+      </p:sp>
+      <p:sp>
+        <p:nvSpPr>
+          <p:cNvPr id="3" name="Text 1"/>
+          <p:cNvSpPr txBox="1"/>
+          <p:nvPr/>
+        </p:nvSpPr>
+        <p:spPr>
+          <a:xfrm>
+            <a:off x="548640" y="1600200"/>
+            <a:ext cx="3657600" cy="457200"/>
+          </a:xfrm>
+          <a:prstGeom prst="rect">
+            <a:avLst/>
+          </a:prstGeom>
+          <a:noFill/>
+          <a:ln/>
+        </p:spPr>
+        <p:txBody>
+          <a:bodyPr wrap="square" lIns="0" tIns="0" rIns="0" bIns="0" rtlCol="0" anchor="ctr"/>
+          <a:lstStyle/>
+          <a:p>
+            <a:pPr indent="0" marL="0">
+              <a:buNone/>
+            </a:pPr>
+            <a:r>
+              <a:rPr lang="en-US" sz="2400" b="1" dirty="0">
+                <a:solidFill>
+                  <a:srgbClr val="0F4C5C"/>
+                </a:solidFill>
+              </a:rPr>
+              <a:t>In Excel</a:t>
+            </a:r>
+            <a:endParaRPr lang="en-US" sz="2400" dirty="0"/>
+          </a:p>
+        </p:txBody>
+      </p:sp>
+      <p:sp>
+        <p:nvSpPr>
+          <p:cNvPr id="4" name="Text 2"/>
+          <p:cNvSpPr txBox="1"/>
+          <p:nvPr/>
+        </p:nvSpPr>
+        <p:spPr>
+          <a:xfrm>
+            <a:off x="548640" y="2103120"/>
+            <a:ext cx="3657600" cy="1097280"/>
+          </a:xfrm>
+          <a:prstGeom prst="rect">
+            <a:avLst/>
+          </a:prstGeom>
+          <a:noFill/>
+          <a:ln/>
+        </p:spPr>
+        <p:txBody>
+          <a:bodyPr wrap="square" lIns="0" tIns="0" rIns="0" bIns="0" rtlCol="0" anchor="t"/>
+          <a:lstStyle/>
+          <a:p>
+            <a:pPr indent="0" marL="0">
+              <a:buNone/>
+            </a:pPr>
+            <a:r>
+              <a:rPr lang="en-US" sz="1800" dirty="0">
+                <a:solidFill>
+                  <a:srgbClr val="1F2A30"/>
+                </a:solidFill>
+              </a:rPr>
+              <a:t>clicchi sulla cella, scrivi 12, invio. Nessuno saprà mai che l'hai fatto.</a:t>
+            </a:r>
+            <a:endParaRPr lang="en-US" sz="1800" dirty="0"/>
+          </a:p>
+        </p:txBody>
+      </p:sp>
+      <p:sp>
+        <p:nvSpPr>
+          <p:cNvPr id="5" name="Text 3"/>
+          <p:cNvSpPr txBox="1"/>
+          <p:nvPr/>
+        </p:nvSpPr>
+        <p:spPr>
+          <a:xfrm>
+            <a:off x="4572000" y="1600200"/>
+            <a:ext cx="7040880" cy="457200"/>
+          </a:xfrm>
+          <a:prstGeom prst="rect">
+            <a:avLst/>
+          </a:prstGeom>
+          <a:noFill/>
+          <a:ln/>
+        </p:spPr>
+        <p:txBody>
+          <a:bodyPr wrap="square" lIns="0" tIns="0" rIns="0" bIns="0" rtlCol="0" anchor="ctr"/>
+          <a:lstStyle/>
+          <a:p>
+            <a:pPr indent="0" marL="0">
+              <a:buNone/>
+            </a:pPr>
+            <a:r>
+              <a:rPr lang="en-US" sz="2400" b="1" dirty="0">
+                <a:solidFill>
+                  <a:srgbClr val="0F4C5C"/>
+                </a:solidFill>
+              </a:rPr>
+              <a:t>In Python</a:t>
+            </a:r>
+            <a:endParaRPr lang="en-US" sz="2400" dirty="0"/>
+          </a:p>
+        </p:txBody>
+      </p:sp>
+      <p:sp>
+        <p:nvSpPr>
+          <p:cNvPr id="6" name="card-code"/>
+          <p:cNvSpPr/>
+          <p:nvPr/>
+        </p:nvSpPr>
+        <p:spPr>
+          <a:xfrm>
+            <a:off x="4572000" y="2103120"/>
+            <a:ext cx="7040880" cy="1828800"/>
+          </a:xfrm>
+          <a:prstGeom prst="roundRect">
+            <a:avLst>
+              <a:gd name="adj" fmla="val 6000"/>
+            </a:avLst>
+          </a:prstGeom>
+          <a:solidFill>
+            <a:srgbClr val="1F2A30"/>
+          </a:solidFill>
+          <a:ln/>
+        </p:spPr>
+      </p:sp>
+      <p:sp>
+        <p:nvSpPr>
+          <p:cNvPr id="7" name="Text 5"/>
+          <p:cNvSpPr txBox="1"/>
+          <p:nvPr/>
+        </p:nvSpPr>
+        <p:spPr>
+          <a:xfrm>
+            <a:off x="4800600" y="2240280"/>
+            <a:ext cx="1828800" cy="274320"/>
+          </a:xfrm>
+          <a:prstGeom prst="rect">
+            <a:avLst/>
+          </a:prstGeom>
+          <a:noFill/>
+          <a:ln/>
+        </p:spPr>
+        <p:txBody>
+          <a:bodyPr wrap="square" lIns="0" tIns="0" rIns="0" bIns="0" rtlCol="0" anchor="ctr"/>
+          <a:lstStyle/>
+          <a:p>
+            <a:pPr indent="0" marL="0">
+              <a:buNone/>
+            </a:pPr>
+            <a:r>
+              <a:rPr lang="en-US" sz="1100" b="1" spc="200" kern="0" dirty="0">
+                <a:solidFill>
+                  <a:srgbClr val="E09F3E"/>
+                </a:solidFill>
+              </a:rPr>
+              <a:t>PYTHON</a:t>
+            </a:r>
+            <a:endParaRPr lang="en-US" sz="1100" dirty="0"/>
+          </a:p>
+        </p:txBody>
+      </p:sp>
+      <p:sp>
+        <p:nvSpPr>
+          <p:cNvPr id="8" name="Text 6"/>
+          <p:cNvSpPr txBox="1"/>
+          <p:nvPr/>
+        </p:nvSpPr>
+        <p:spPr>
+          <a:xfrm>
+            <a:off x="4800600" y="2560320"/>
+            <a:ext cx="6583680" cy="1234440"/>
+          </a:xfrm>
+          <a:prstGeom prst="rect">
+            <a:avLst/>
+          </a:prstGeom>
+          <a:noFill/>
+          <a:ln/>
+        </p:spPr>
+        <p:txBody>
+          <a:bodyPr wrap="square" lIns="0" tIns="0" rIns="0" bIns="0" rtlCol="0" anchor="t"/>
+          <a:lstStyle/>
+          <a:p>
+            <a:pPr indent="0" marL="0">
+              <a:buNone/>
+            </a:pPr>
+            <a:r>
+              <a:rPr lang="en-US" sz="1600" dirty="0">
                 <a:solidFill>
                   <a:srgbClr val="FFFFFF"/>
                 </a:solidFill>
-              </a:rPr>
-              <a:t>Task: pulisci il dataset</a:t>
-            </a:r>
-            <a:endParaRPr lang="en-US" sz="5400" dirty="0"/>
-          </a:p>
-        </p:txBody>
-      </p:sp>
-      <p:sp>
-        <p:nvSpPr>
-          <p:cNvPr id="3" name="Text 0"/>
+                <a:latin typeface="Courier New" pitchFamily="34" charset="0"/>
+                <a:ea typeface="Courier New" pitchFamily="34" charset="-122"/>
+                <a:cs typeface="Courier New" pitchFamily="34" charset="-120"/>
+              </a:rPr>
+              <a:t>riga = ((df["cliente"] == "C042")</a:t>
+            </a:r>
+            <a:endParaRPr lang="en-US" sz="1600" dirty="0"/>
+          </a:p>
+          <a:p>
+            <a:pPr indent="0" marL="0">
+              <a:buNone/>
+            </a:pPr>
+            <a:r>
+              <a:rPr lang="en-US" sz="1600" dirty="0">
+                <a:solidFill>
+                  <a:srgbClr val="FFFFFF"/>
+                </a:solidFill>
+                <a:latin typeface="Courier New" pitchFamily="34" charset="0"/>
+                <a:ea typeface="Courier New" pitchFamily="34" charset="-122"/>
+                <a:cs typeface="Courier New" pitchFamily="34" charset="-120"/>
+              </a:rPr>
+              <a:t>        &amp; (df["anno"] == 2021))</a:t>
+            </a:r>
+            <a:endParaRPr lang="en-US" sz="1600" dirty="0"/>
+          </a:p>
+          <a:p>
+            <a:pPr indent="0" marL="0">
+              <a:buNone/>
+            </a:pPr>
+            <a:r>
+              <a:rPr lang="en-US" sz="1600" dirty="0">
+                <a:solidFill>
+                  <a:srgbClr val="FFFFFF"/>
+                </a:solidFill>
+                <a:latin typeface="Courier New" pitchFamily="34" charset="0"/>
+                <a:ea typeface="Courier New" pitchFamily="34" charset="-122"/>
+                <a:cs typeface="Courier New" pitchFamily="34" charset="-120"/>
+              </a:rPr>
+              <a:t>print(riga.sum())     # deve dare 1</a:t>
+            </a:r>
+            <a:endParaRPr lang="en-US" sz="1600" dirty="0"/>
+          </a:p>
+          <a:p>
+            <a:pPr indent="0" marL="0">
+              <a:buNone/>
+            </a:pPr>
+            <a:r>
+              <a:rPr lang="en-US" sz="1600" dirty="0">
+                <a:solidFill>
+                  <a:srgbClr val="FFFFFF"/>
+                </a:solidFill>
+                <a:latin typeface="Courier New" pitchFamily="34" charset="0"/>
+                <a:ea typeface="Courier New" pitchFamily="34" charset="-122"/>
+                <a:cs typeface="Courier New" pitchFamily="34" charset="-120"/>
+              </a:rPr>
+              <a:t>df.loc[riga, "ordini"] = 12</a:t>
+            </a:r>
+            <a:endParaRPr lang="en-US" sz="1600" dirty="0"/>
+          </a:p>
+        </p:txBody>
+      </p:sp>
+      <p:sp>
+        <p:nvSpPr>
+          <p:cNvPr id="9" name="Shape 7"/>
           <p:cNvSpPr/>
+          <p:nvPr/>
+        </p:nvSpPr>
+        <p:spPr>
+          <a:xfrm>
+            <a:off x="548640" y="4251960"/>
+            <a:ext cx="5440680" cy="1325880"/>
+          </a:xfrm>
+          <a:prstGeom prst="roundRect">
+            <a:avLst>
+              <a:gd name="adj" fmla="val 8276"/>
+            </a:avLst>
+          </a:prstGeom>
+          <a:solidFill>
+            <a:srgbClr val="EEF3F4"/>
+          </a:solidFill>
+          <a:ln/>
+        </p:spPr>
+      </p:sp>
+      <p:sp>
+        <p:nvSpPr>
+          <p:cNvPr id="10" name="Shape 8"/>
+          <p:cNvSpPr/>
+          <p:nvPr/>
+        </p:nvSpPr>
+        <p:spPr>
+          <a:xfrm>
+            <a:off x="822960" y="4553712"/>
+            <a:ext cx="685800" cy="685800"/>
+          </a:xfrm>
+          <a:prstGeom prst="ellipse">
+            <a:avLst/>
+          </a:prstGeom>
+          <a:solidFill>
+            <a:srgbClr val="E09F3E"/>
+          </a:solidFill>
+          <a:ln/>
+        </p:spPr>
+      </p:sp>
+      <p:sp>
+        <p:nvSpPr>
+          <p:cNvPr id="11" name="Text 9"/>
+          <p:cNvSpPr txBox="1"/>
+          <p:nvPr/>
+        </p:nvSpPr>
+        <p:spPr>
+          <a:xfrm>
+            <a:off x="822960" y="4553712"/>
+            <a:ext cx="685800" cy="685800"/>
+          </a:xfrm>
+          <a:prstGeom prst="rect">
+            <a:avLst/>
+          </a:prstGeom>
+          <a:noFill/>
+          <a:ln/>
+        </p:spPr>
+        <p:txBody>
+          <a:bodyPr wrap="square" lIns="0" tIns="0" rIns="0" bIns="0" rtlCol="0" anchor="ctr"/>
+          <a:lstStyle/>
+          <a:p>
+            <a:pPr algn="ctr" indent="0" marL="0">
+              <a:buNone/>
+            </a:pPr>
+            <a:r>
+              <a:rPr lang="en-US" sz="1950" b="1" dirty="0">
+                <a:solidFill>
+                  <a:srgbClr val="1F2A30"/>
+                </a:solidFill>
+              </a:rPr>
+              <a:t>1</a:t>
+            </a:r>
+            <a:endParaRPr lang="en-US" sz="1950" dirty="0"/>
+          </a:p>
+        </p:txBody>
+      </p:sp>
+      <p:sp>
+        <p:nvSpPr>
+          <p:cNvPr id="12" name="Text 10"/>
+          <p:cNvSpPr txBox="1"/>
+          <p:nvPr/>
+        </p:nvSpPr>
+        <p:spPr>
+          <a:xfrm>
+            <a:off x="1737360" y="4434840"/>
+            <a:ext cx="4069080" cy="457200"/>
+          </a:xfrm>
+          <a:prstGeom prst="rect">
+            <a:avLst/>
+          </a:prstGeom>
+          <a:noFill/>
+          <a:ln/>
+        </p:spPr>
+        <p:txBody>
+          <a:bodyPr wrap="square" lIns="0" tIns="0" rIns="0" bIns="0" rtlCol="0" anchor="ctr"/>
+          <a:lstStyle/>
+          <a:p>
+            <a:pPr indent="0" marL="0">
+              <a:buNone/>
+            </a:pPr>
+            <a:r>
+              <a:rPr lang="en-US" sz="2000" b="1" dirty="0">
+                <a:solidFill>
+                  <a:srgbClr val="1F2A30"/>
+                </a:solidFill>
+              </a:rPr>
+              <a:t>Sempre nel codice</a:t>
+            </a:r>
+            <a:endParaRPr lang="en-US" sz="2000" dirty="0"/>
+          </a:p>
+        </p:txBody>
+      </p:sp>
+      <p:sp>
+        <p:nvSpPr>
+          <p:cNvPr id="13" name="Text 11"/>
+          <p:cNvSpPr txBox="1"/>
+          <p:nvPr/>
+        </p:nvSpPr>
+        <p:spPr>
+          <a:xfrm>
+            <a:off x="1737360" y="4892040"/>
+            <a:ext cx="4069080" cy="502920"/>
+          </a:xfrm>
+          <a:prstGeom prst="rect">
+            <a:avLst/>
+          </a:prstGeom>
+          <a:noFill/>
+          <a:ln/>
+        </p:spPr>
+        <p:txBody>
+          <a:bodyPr wrap="square" lIns="0" tIns="0" rIns="0" bIns="0" rtlCol="0" anchor="ctr"/>
+          <a:lstStyle/>
+          <a:p>
+            <a:pPr indent="0" marL="0">
+              <a:buNone/>
+            </a:pPr>
+            <a:r>
+              <a:rPr lang="en-US" sz="1600" dirty="0">
+                <a:solidFill>
+                  <a:srgbClr val="5C6F7B"/>
+                </a:solidFill>
+              </a:rPr>
+              <a:t>la correzione resta scritta e si può rifare</a:t>
+            </a:r>
+            <a:endParaRPr lang="en-US" sz="1600" dirty="0"/>
+          </a:p>
+        </p:txBody>
+      </p:sp>
+      <p:sp>
+        <p:nvSpPr>
+          <p:cNvPr id="14" name="Shape 12"/>
+          <p:cNvSpPr/>
+          <p:nvPr/>
+        </p:nvSpPr>
+        <p:spPr>
+          <a:xfrm>
+            <a:off x="6172200" y="4251960"/>
+            <a:ext cx="5440680" cy="1325880"/>
+          </a:xfrm>
+          <a:prstGeom prst="roundRect">
+            <a:avLst>
+              <a:gd name="adj" fmla="val 8276"/>
+            </a:avLst>
+          </a:prstGeom>
+          <a:solidFill>
+            <a:srgbClr val="EEF3F4"/>
+          </a:solidFill>
+          <a:ln/>
+        </p:spPr>
+      </p:sp>
+      <p:sp>
+        <p:nvSpPr>
+          <p:cNvPr id="15" name="Shape 13"/>
+          <p:cNvSpPr/>
+          <p:nvPr/>
+        </p:nvSpPr>
+        <p:spPr>
+          <a:xfrm>
+            <a:off x="6446520" y="4553712"/>
+            <a:ext cx="685800" cy="685800"/>
+          </a:xfrm>
+          <a:prstGeom prst="ellipse">
+            <a:avLst/>
+          </a:prstGeom>
+          <a:solidFill>
+            <a:srgbClr val="E09F3E"/>
+          </a:solidFill>
+          <a:ln/>
+        </p:spPr>
+      </p:sp>
+      <p:sp>
+        <p:nvSpPr>
+          <p:cNvPr id="16" name="Text 14"/>
+          <p:cNvSpPr txBox="1"/>
+          <p:nvPr/>
+        </p:nvSpPr>
+        <p:spPr>
+          <a:xfrm>
+            <a:off x="6446520" y="4553712"/>
+            <a:ext cx="685800" cy="685800"/>
+          </a:xfrm>
+          <a:prstGeom prst="rect">
+            <a:avLst/>
+          </a:prstGeom>
+          <a:noFill/>
+          <a:ln/>
+        </p:spPr>
+        <p:txBody>
+          <a:bodyPr wrap="square" lIns="0" tIns="0" rIns="0" bIns="0" rtlCol="0" anchor="ctr"/>
+          <a:lstStyle/>
+          <a:p>
+            <a:pPr algn="ctr" indent="0" marL="0">
+              <a:buNone/>
+            </a:pPr>
+            <a:r>
+              <a:rPr lang="en-US" sz="1950" b="1" dirty="0">
+                <a:solidFill>
+                  <a:srgbClr val="1F2A30"/>
+                </a:solidFill>
+              </a:rPr>
+              <a:t>2</a:t>
+            </a:r>
+            <a:endParaRPr lang="en-US" sz="1950" dirty="0"/>
+          </a:p>
+        </p:txBody>
+      </p:sp>
+      <p:sp>
+        <p:nvSpPr>
+          <p:cNvPr id="17" name="Text 15"/>
+          <p:cNvSpPr txBox="1"/>
+          <p:nvPr/>
+        </p:nvSpPr>
+        <p:spPr>
+          <a:xfrm>
+            <a:off x="7360920" y="4434840"/>
+            <a:ext cx="4069080" cy="457200"/>
+          </a:xfrm>
+          <a:prstGeom prst="rect">
+            <a:avLst/>
+          </a:prstGeom>
+          <a:noFill/>
+          <a:ln/>
+        </p:spPr>
+        <p:txBody>
+          <a:bodyPr wrap="square" lIns="0" tIns="0" rIns="0" bIns="0" rtlCol="0" anchor="ctr"/>
+          <a:lstStyle/>
+          <a:p>
+            <a:pPr indent="0" marL="0">
+              <a:buNone/>
+            </a:pPr>
+            <a:r>
+              <a:rPr lang="en-US" sz="2000" b="1" dirty="0">
+                <a:solidFill>
+                  <a:srgbClr val="1F2A30"/>
+                </a:solidFill>
+              </a:rPr>
+              <a:t>Per contenuto, non per numero di riga</a:t>
+            </a:r>
+            <a:endParaRPr lang="en-US" sz="2000" dirty="0"/>
+          </a:p>
+        </p:txBody>
+      </p:sp>
+      <p:sp>
+        <p:nvSpPr>
+          <p:cNvPr id="18" name="Text 16"/>
+          <p:cNvSpPr txBox="1"/>
+          <p:nvPr/>
+        </p:nvSpPr>
+        <p:spPr>
+          <a:xfrm>
+            <a:off x="7360920" y="4892040"/>
+            <a:ext cx="4069080" cy="502920"/>
+          </a:xfrm>
+          <a:prstGeom prst="rect">
+            <a:avLst/>
+          </a:prstGeom>
+          <a:noFill/>
+          <a:ln/>
+        </p:spPr>
+        <p:txBody>
+          <a:bodyPr wrap="square" lIns="0" tIns="0" rIns="0" bIns="0" rtlCol="0" anchor="ctr"/>
+          <a:lstStyle/>
+          <a:p>
+            <a:pPr indent="0" marL="0">
+              <a:buNone/>
+            </a:pPr>
+            <a:r>
+              <a:rPr lang="en-US" sz="1600" dirty="0">
+                <a:solidFill>
+                  <a:srgbClr val="5C6F7B"/>
+                </a:solidFill>
+              </a:rPr>
+              <a:t>dopo un ordinamento la riga 500 è un'altra</a:t>
+            </a:r>
+            <a:endParaRPr lang="en-US" sz="1600" dirty="0"/>
+          </a:p>
+        </p:txBody>
+      </p:sp>
+      <p:sp>
+        <p:nvSpPr>
+          <p:cNvPr id="19" name="Text 17"/>
+          <p:cNvSpPr txBox="1"/>
+          <p:nvPr/>
+        </p:nvSpPr>
+        <p:spPr>
+          <a:xfrm>
+            <a:off x="548640" y="5760720"/>
+            <a:ext cx="11064240" cy="411480"/>
+          </a:xfrm>
+          <a:prstGeom prst="rect">
+            <a:avLst/>
+          </a:prstGeom>
+          <a:noFill/>
+          <a:ln/>
+        </p:spPr>
+        <p:txBody>
+          <a:bodyPr wrap="square" lIns="0" tIns="0" rIns="0" bIns="0" rtlCol="0" anchor="ctr"/>
+          <a:lstStyle/>
+          <a:p>
+            <a:pPr indent="0" marL="0">
+              <a:buNone/>
+            </a:pPr>
+            <a:r>
+              <a:rPr lang="en-US" sz="1700" i="1" dirty="0">
+                <a:solidFill>
+                  <a:srgbClr val="0F4C5C"/>
+                </a:solidFill>
+              </a:rPr>
+              <a:t>Due condizioni insieme: &amp;, e ognuna tra parentesi.</a:t>
+            </a:r>
+            <a:endParaRPr lang="en-US" sz="1700" dirty="0"/>
+          </a:p>
+        </p:txBody>
+      </p:sp>
+      <p:sp>
+        <p:nvSpPr>
+          <p:cNvPr id="25" name="Slide Number Placeholder 0"/>
+          <p:cNvSpPr>
+            <a:spLocks noGrp="1"/>
+          </p:cNvSpPr>
           <p:nvPr>
-            <p:ph idx="101" type="body" hasCustomPrompt="1"/>
+            <p:ph type="sldNum" sz="quarter" idx="4294967295"/>
           </p:nvPr>
         </p:nvSpPr>
         <p:spPr>
           <a:xfrm>
-            <a:off x="731520" y="3657600"/>
-            <a:ext cx="10698480" cy="1463040"/>
-          </a:xfrm>
-          <a:prstGeom prst="rect">
-            <a:avLst/>
-          </a:prstGeom>
-          <a:noFill/>
-          <a:ln/>
-        </p:spPr>
-        <p:txBody>
-          <a:bodyPr wrap="square" lIns="0" tIns="0" rIns="0" bIns="0" rtlCol="0" anchor="t"/>
-          <a:lstStyle/>
-          <a:p>
-            <a:pPr indent="0" marL="0">
-              <a:buNone/>
-            </a:pPr>
-            <a:r>
-              <a:rPr lang="en-US" sz="2200" dirty="0">
-                <a:solidFill>
-                  <a:srgbClr val="B8C4CB"/>
-                </a:solidFill>
-              </a:rPr>
-              <a:t>Obiettivo: 2.500 righe, 20 regioni, un fatturato numerico e plausibile.</a:t>
-            </a:r>
-            <a:endParaRPr lang="en-US" sz="2200" dirty="0"/>
-          </a:p>
-          <a:p>
-            <a:pPr indent="0" marL="0">
-              <a:buNone/>
-            </a:pPr>
-            <a:r>
-              <a:rPr lang="en-US" sz="2200" dirty="0">
-                <a:solidFill>
-                  <a:srgbClr val="B8C4CB"/>
-                </a:solidFill>
-              </a:rPr>
-              <a:t>60 minuti · apri il notebook dal README</a:t>
-            </a:r>
-            <a:endParaRPr lang="en-US" sz="2200" dirty="0"/>
+            <a:off x="11155680" y="6400800"/>
+            <a:ext cx="457200" cy="274320"/>
+          </a:xfrm>
+          <a:prstGeom prst="rect">
+            <a:avLst/>
+          </a:prstGeom>
+          <a:extLst>
+            <a:ext uri="{C572A759-6A51-4108-AA02-DFA0A04FC94B}">
+              <ma14:wrappingTextBoxFlag xmlns:ma14="http://schemas.microsoft.com/office/mac/drawingml/2011/main" val="0"/>
+            </a:ext>
+          </a:extLst>
+        </p:spPr>
+        <p:txBody>
+          <a:bodyPr/>
+          <a:lstStyle>
+            <a:lvl1pPr>
+              <a:defRPr sz="1000">
+                <a:solidFill>
+                  <a:srgbClr val="5C6F7B"/>
+                </a:solidFill>
+              </a:defRPr>
+            </a:lvl1pPr>
+          </a:lstStyle>
+          <a:p>
+            <a:pPr algn="r"/>
+            <a:fld id="{F7021451-1387-4CA6-816F-3879F97B5CBC}" type="slidenum">
+              <a:rPr b="0" lang="en-US"/>
+              <a:t>8</a:t>
+            </a:fld>
+            <a:endParaRPr lang="en-US"/>
           </a:p>
         </p:txBody>
       </p:sp>
@@ -5508,8 +6284,8 @@
         </p:nvSpPr>
         <p:spPr>
           <a:xfrm>
-            <a:off x="731520" y="2103120"/>
-            <a:ext cx="10698480" cy="1463040"/>
+            <a:off x="731520" y="2194560"/>
+            <a:ext cx="10698480" cy="1280160"/>
           </a:xfrm>
           <a:prstGeom prst="rect">
             <a:avLst/>
@@ -5525,14 +6301,14 @@
               <a:buNone/>
             </a:pPr>
             <a:r>
-              <a:rPr lang="en-US" sz="4800" b="1" dirty="0">
+              <a:rPr lang="en-US" sz="5400" b="1" dirty="0">
                 <a:solidFill>
                   <a:srgbClr val="FFFFFF"/>
                 </a:solidFill>
               </a:rPr>
-              <a:t>Prossima volta: raggruppare e disegnare</a:t>
-            </a:r>
-            <a:endParaRPr lang="en-US" sz="4800" dirty="0"/>
+              <a:t>Task: pulisci il dataset</a:t>
+            </a:r>
+            <a:endParaRPr lang="en-US" sz="5400" dirty="0"/>
           </a:p>
         </p:txBody>
       </p:sp>
@@ -5546,8 +6322,8 @@
         </p:nvSpPr>
         <p:spPr>
           <a:xfrm>
-            <a:off x="731520" y="3749040"/>
-            <a:ext cx="10698480" cy="914400"/>
+            <a:off x="731520" y="3657600"/>
+            <a:ext cx="10698480" cy="1463040"/>
           </a:xfrm>
           <a:prstGeom prst="rect">
             <a:avLst/>
@@ -5565,10 +6341,24 @@
             <a:r>
               <a:rPr lang="en-US" sz="2200" dirty="0">
                 <a:solidFill>
-                  <a:srgbClr val="F4C06E"/>
-                </a:solidFill>
-              </a:rPr>
-              <a:t>Compito: Kaggle Learn – Pandas, «Data Types and Missing Values» (~20 min)</a:t>
+                  <a:srgbClr val="B8C4CB"/>
+                </a:solidFill>
+              </a:rPr>
+              <a:t>Obiettivo: 2.500 righe, 20 regioni, un fatturato numerico e plausibile.</a:t>
+            </a:r>
+            <a:endParaRPr lang="en-US" sz="2200" dirty="0"/>
+          </a:p>
+          <a:p>
+            <a:pPr indent="0" marL="0">
+              <a:buNone/>
+            </a:pPr>
+            <a:r>
+              <a:rPr lang="en-US" sz="2200" dirty="0">
+                <a:solidFill>
+                  <a:srgbClr val="B8C4CB"/>
+                </a:solidFill>
+              </a:rPr>
+              <a:t>60 minuti · apri il notebook dal README</a:t>
             </a:r>
             <a:endParaRPr lang="en-US" sz="2200" dirty="0"/>
           </a:p>

</xml_diff>

<commit_message>
L3: introduzione ai dizionari
Slide, sezione della dispensa e passo di riscaldamento nel task, prima di usarli con replace. L6: la sezione diventa un ripasso.

Co-Authored-By: Claude Opus 5.5 <noreply@anthropic.com>
Claude-Session: https://claude.ai/code/session_014CzWDFXvYNxqLeD99LSN3G
</commit_message>
<xml_diff>
--- a/lezioni/L03_pulizia/slide.pptx
+++ b/lezioni/L03_pulizia/slide.pptx
@@ -15,9 +15,10 @@
     <p:sldId id="263" r:id="rId9"/>
     <p:sldId id="264" r:id="rId10"/>
     <p:sldId id="265" r:id="rId11"/>
+    <p:sldId id="266" r:id="rId12"/>
   </p:sldIdLst>
   <p:notesMasterIdLst>
-    <p:notesMasterId r:id="rId12"/>
+    <p:notesMasterId r:id="rId13"/>
   </p:notesMasterIdLst>
   <p:sldSz cx="12192000" cy="6858000"/>
   <p:notesSz cx="6858000" cy="12192000"/>
@@ -116,13 +117,13 @@
   <p:extLst>
     <p:ext uri="{521415D9-36F7-43E2-AB2F-B90AF26B5E84}">
       <p14:sectionLst xmlns:p14="http://schemas.microsoft.com/office/powerpoint/2010/main">
-        <p14:section name="Apertura" id="{b4cfa0a0-58e7-7efc-7644-5ed1553c8581}">
+        <p14:section name="Apertura" id="{2b10fd5c-ff57-4372-075e-192f320860ca}">
           <p14:sldIdLst>
             <p14:sldId id="256"/>
             <p14:sldId id="257"/>
           </p14:sldIdLst>
         </p14:section>
-        <p14:section name="Spiegazione" id="{fe60a480-783b-3f9e-960c-847513db0732}">
+        <p14:section name="Spiegazione" id="{ea7b25f7-3283-5d99-b22d-951752d109b6}">
           <p14:sldIdLst>
             <p14:sldId id="258"/>
             <p14:sldId id="259"/>
@@ -130,16 +131,17 @@
             <p14:sldId id="261"/>
             <p14:sldId id="262"/>
             <p14:sldId id="263"/>
-          </p14:sldIdLst>
-        </p14:section>
-        <p14:section name="Task" id="{fa147481-25f1-b82c-ce81-da24abb09dce}">
-          <p14:sldIdLst>
             <p14:sldId id="264"/>
           </p14:sldIdLst>
         </p14:section>
-        <p14:section name="Chiusura" id="{3392d9f0-a8c3-aa7b-2713-24e68fab6142}">
+        <p14:section name="Task" id="{63f54a1e-c192-4a83-319a-694c0190bb7b}">
           <p14:sldIdLst>
             <p14:sldId id="265"/>
+          </p14:sldIdLst>
+        </p14:section>
+        <p14:section name="Chiusura" id="{1a1f5952-83a4-5cec-a6d0-126946cd0859}">
+          <p14:sldIdLst>
+            <p14:sldId id="266"/>
           </p14:sldIdLst>
         </p14:section>
       </p14:sectionLst>
@@ -634,7 +636,7 @@
           <a:p>
             <a:r>
               <a:rPr lang="en-US" dirty="0"/>
-              <a:t/>
+              <a:t>Girando tra i banchi: tenere d'occhio il passo 5. Chi trova più di 50 mancanti ha sbagliato l'ordine delle sostituzioni: non dirglielo, chiedergli se il numero torna.</a:t>
             </a:r>
             <a:endParaRPr lang="en-US" dirty="0"/>
           </a:p>
@@ -658,6 +660,94 @@
             <a:fld id="{F7021451-1387-4CA6-816F-3879F97B5CBC}" type="slidenum">
               <a:rPr lang="en-US"/>
               <a:t>10</a:t>
+            </a:fld>
+            <a:endParaRPr lang="en-US"/>
+          </a:p>
+        </p:txBody>
+      </p:sp>
+    </p:spTree>
+    <p:extLst>
+      <p:ext uri="{BB962C8B-B14F-4D97-AF65-F5344CB8AC3E}">
+        <p14:creationId xmlns:p14="http://schemas.microsoft.com/office/powerpoint/2010/main" val="1024086991"/>
+      </p:ext>
+    </p:extLst>
+  </p:cSld>
+  <p:clrMapOvr>
+    <a:masterClrMapping/>
+  </p:clrMapOvr>
+</p:notes>
+</file>
+
+<file path=ppt/notesSlides/notesSlide11.xml><?xml version="1.0" encoding="utf-8"?>
+<p:notes xmlns:a="http://schemas.openxmlformats.org/drawingml/2006/main" xmlns:r="http://schemas.openxmlformats.org/officeDocument/2006/relationships" xmlns:p="http://schemas.openxmlformats.org/presentationml/2006/main">
+  <p:cSld>
+    <p:spTree>
+      <p:nvGrpSpPr>
+        <p:cNvPr id="1" name=""/>
+        <p:cNvGrpSpPr/>
+        <p:nvPr/>
+      </p:nvGrpSpPr>
+      <p:grpSpPr>
+        <a:xfrm>
+          <a:off x="0" y="0"/>
+          <a:ext cx="0" cy="0"/>
+          <a:chOff x="0" y="0"/>
+          <a:chExt cx="0" cy="0"/>
+        </a:xfrm>
+      </p:grpSpPr>
+      <p:sp>
+        <p:nvSpPr>
+          <p:cNvPr id="2" name="Slide Image Placeholder 1"/>
+          <p:cNvSpPr>
+            <a:spLocks noGrp="1" noRot="1" noChangeAspect="1"/>
+          </p:cNvSpPr>
+          <p:nvPr>
+            <p:ph type="sldImg"/>
+          </p:nvPr>
+        </p:nvSpPr>
+        <p:spPr/>
+      </p:sp>
+      <p:sp>
+        <p:nvSpPr>
+          <p:cNvPr id="3" name="Notes Placeholder 2"/>
+          <p:cNvSpPr>
+            <a:spLocks noGrp="1"/>
+          </p:cNvSpPr>
+          <p:nvPr>
+            <p:ph type="body" idx="1"/>
+          </p:nvPr>
+        </p:nvSpPr>
+        <p:spPr/>
+        <p:txBody>
+          <a:bodyPr/>
+          <a:lstStyle/>
+          <a:p>
+            <a:r>
+              <a:rPr lang="en-US" dirty="0"/>
+              <a:t/>
+            </a:r>
+            <a:endParaRPr lang="en-US" dirty="0"/>
+          </a:p>
+        </p:txBody>
+      </p:sp>
+      <p:sp>
+        <p:nvSpPr>
+          <p:cNvPr id="4" name="Slide Number Placeholder 3"/>
+          <p:cNvSpPr>
+            <a:spLocks noGrp="1"/>
+          </p:cNvSpPr>
+          <p:nvPr>
+            <p:ph type="sldNum" sz="quarter" idx="10"/>
+          </p:nvPr>
+        </p:nvSpPr>
+        <p:spPr/>
+        <p:txBody>
+          <a:bodyPr/>
+          <a:lstStyle/>
+          <a:p>
+            <a:fld id="{F7021451-1387-4CA6-816F-3879F97B5CBC}" type="slidenum">
+              <a:rPr lang="en-US"/>
+              <a:t>11</a:t>
             </a:fld>
             <a:endParaRPr lang="en-US"/>
           </a:p>
@@ -1074,7 +1164,7 @@
           <a:p>
             <a:r>
               <a:rPr lang="en-US" dirty="0"/>
-              <a:t>Il caso "12,5": la virgola italiana non è un decimale per Python. Non anticipare la soluzione del task: lasciare che ci arrivino.</a:t>
+              <a:t>Concetto nuovo ma piccolo. Il passo 9 del task è un riscaldamento sui dizionari prima di usarli con replace. Torneranno nella L5 e nella L6 (per far restituire più risultati a una funzione).</a:t>
             </a:r>
             <a:endParaRPr lang="en-US" dirty="0"/>
           </a:p>
@@ -1162,7 +1252,7 @@
           <a:p>
             <a:r>
               <a:rPr lang="en-US" dirty="0"/>
-              <a:t>isna().sum() per contare i mancanti di ogni colonna: lo cercano nel task.</a:t>
+              <a:t>Il caso "12,5": la virgola italiana non è un decimale per Python. Non anticipare la soluzione del task: lasciare che ci arrivino.</a:t>
             </a:r>
             <a:endParaRPr lang="en-US" dirty="0"/>
           </a:p>
@@ -1250,7 +1340,7 @@
           <a:p>
             <a:r>
               <a:rPr lang="en-US" dirty="0"/>
-              <a:t>L'esempio usa un dataset inventato (clienti e ordini) per non anticipare il task. Insistere sul controllo riga.sum() == 1 prima di modificare: se dà 0 la condizione è sbagliata, se dà più di 1 stai per cambiare più celle.</a:t>
+              <a:t>isna().sum() per contare i mancanti di ogni colonna: lo cercano nel task.</a:t>
             </a:r>
             <a:endParaRPr lang="en-US" dirty="0"/>
           </a:p>
@@ -1338,7 +1428,7 @@
           <a:p>
             <a:r>
               <a:rPr lang="en-US" dirty="0"/>
-              <a:t>Girando tra i banchi: tenere d'occhio il passo 5. Chi trova più di 50 mancanti ha sbagliato l'ordine delle sostituzioni: non dirglielo, chiedergli se il numero torna.</a:t>
+              <a:t>L'esempio usa un dataset inventato (clienti e ordini) per non anticipare il task. Insistere sul controllo riga.sum() == 1 prima di modificare: se dà 0 la condizione è sbagliata, se dà più di 1 stai per cambiare più celle.</a:t>
             </a:r>
             <a:endParaRPr lang="en-US" dirty="0"/>
           </a:p>
@@ -2235,6 +2325,121 @@
         </p:nvSpPr>
         <p:spPr>
           <a:xfrm>
+            <a:off x="731520" y="2194560"/>
+            <a:ext cx="10698480" cy="1280160"/>
+          </a:xfrm>
+          <a:prstGeom prst="rect">
+            <a:avLst/>
+          </a:prstGeom>
+          <a:noFill/>
+          <a:ln/>
+        </p:spPr>
+        <p:txBody>
+          <a:bodyPr wrap="square" lIns="0" tIns="0" rIns="0" bIns="0" rtlCol="0" anchor="b"/>
+          <a:lstStyle/>
+          <a:p>
+            <a:pPr algn="l" indent="0" marL="0">
+              <a:buNone/>
+            </a:pPr>
+            <a:r>
+              <a:rPr lang="en-US" sz="5400" b="1" dirty="0">
+                <a:solidFill>
+                  <a:srgbClr val="FFFFFF"/>
+                </a:solidFill>
+              </a:rPr>
+              <a:t>Task: pulisci il dataset</a:t>
+            </a:r>
+            <a:endParaRPr lang="en-US" sz="5400" dirty="0"/>
+          </a:p>
+        </p:txBody>
+      </p:sp>
+      <p:sp>
+        <p:nvSpPr>
+          <p:cNvPr id="3" name="Text 0"/>
+          <p:cNvSpPr/>
+          <p:nvPr>
+            <p:ph idx="101" type="body" hasCustomPrompt="1"/>
+          </p:nvPr>
+        </p:nvSpPr>
+        <p:spPr>
+          <a:xfrm>
+            <a:off x="731520" y="3657600"/>
+            <a:ext cx="10698480" cy="1463040"/>
+          </a:xfrm>
+          <a:prstGeom prst="rect">
+            <a:avLst/>
+          </a:prstGeom>
+          <a:noFill/>
+          <a:ln/>
+        </p:spPr>
+        <p:txBody>
+          <a:bodyPr wrap="square" lIns="0" tIns="0" rIns="0" bIns="0" rtlCol="0" anchor="t"/>
+          <a:lstStyle/>
+          <a:p>
+            <a:pPr indent="0" marL="0">
+              <a:buNone/>
+            </a:pPr>
+            <a:r>
+              <a:rPr lang="en-US" sz="2200" dirty="0">
+                <a:solidFill>
+                  <a:srgbClr val="B8C4CB"/>
+                </a:solidFill>
+              </a:rPr>
+              <a:t>Obiettivo: 2.500 righe, 20 regioni, un fatturato numerico e plausibile.</a:t>
+            </a:r>
+            <a:endParaRPr lang="en-US" sz="2200" dirty="0"/>
+          </a:p>
+          <a:p>
+            <a:pPr indent="0" marL="0">
+              <a:buNone/>
+            </a:pPr>
+            <a:r>
+              <a:rPr lang="en-US" sz="2200" dirty="0">
+                <a:solidFill>
+                  <a:srgbClr val="B8C4CB"/>
+                </a:solidFill>
+              </a:rPr>
+              <a:t>60 minuti · apri il notebook dal README</a:t>
+            </a:r>
+            <a:endParaRPr lang="en-US" sz="2200" dirty="0"/>
+          </a:p>
+        </p:txBody>
+      </p:sp>
+    </p:spTree>
+  </p:cSld>
+  <p:clrMapOvr>
+    <a:masterClrMapping/>
+  </p:clrMapOvr>
+</p:sld>
+</file>
+
+<file path=ppt/slides/slide11.xml><?xml version="1.0" encoding="utf-8"?>
+<p:sld xmlns:a="http://schemas.openxmlformats.org/drawingml/2006/main" xmlns:r="http://schemas.openxmlformats.org/officeDocument/2006/relationships" xmlns:p="http://schemas.openxmlformats.org/presentationml/2006/main">
+  <p:cSld name="Slide 11">
+    <p:spTree>
+      <p:nvGrpSpPr>
+        <p:cNvPr id="1" name=""/>
+        <p:cNvGrpSpPr/>
+        <p:nvPr/>
+      </p:nvGrpSpPr>
+      <p:grpSpPr>
+        <a:xfrm>
+          <a:off x="0" y="0"/>
+          <a:ext cx="0" cy="0"/>
+          <a:chOff x="0" y="0"/>
+          <a:chExt cx="0" cy="0"/>
+        </a:xfrm>
+      </p:grpSpPr>
+      <p:sp>
+        <p:nvSpPr>
+          <p:cNvPr id="2" name="Text 0"/>
+          <p:cNvSpPr/>
+          <p:nvPr>
+            <p:ph idx="100" type="title" hasCustomPrompt="1"/>
+          </p:nvPr>
+        </p:nvSpPr>
+        <p:spPr>
+          <a:xfrm>
             <a:off x="731520" y="2103120"/>
             <a:ext cx="10698480" cy="1463040"/>
           </a:xfrm>
@@ -4704,7 +4909,7 @@
                   <a:srgbClr val="0F4C5C"/>
                 </a:solidFill>
               </a:rPr>
-              <a:t>Da testo a numero</a:t>
+              <a:t>I dizionari: coppie chiave → valore</a:t>
             </a:r>
             <a:endParaRPr lang="en-US" sz="3600" dirty="0"/>
           </a:p>
@@ -4719,6 +4924,314 @@
         <p:spPr>
           <a:xfrm>
             <a:off x="548640" y="1737360"/>
+            <a:ext cx="6583680" cy="1188720"/>
+          </a:xfrm>
+          <a:prstGeom prst="roundRect">
+            <a:avLst>
+              <a:gd name="adj" fmla="val 9231"/>
+            </a:avLst>
+          </a:prstGeom>
+          <a:solidFill>
+            <a:srgbClr val="1F2A30"/>
+          </a:solidFill>
+          <a:ln/>
+        </p:spPr>
+      </p:sp>
+      <p:sp>
+        <p:nvSpPr>
+          <p:cNvPr id="4" name="Text 2"/>
+          <p:cNvSpPr txBox="1"/>
+          <p:nvPr/>
+        </p:nvSpPr>
+        <p:spPr>
+          <a:xfrm>
+            <a:off x="777240" y="1874520"/>
+            <a:ext cx="1828800" cy="274320"/>
+          </a:xfrm>
+          <a:prstGeom prst="rect">
+            <a:avLst/>
+          </a:prstGeom>
+          <a:noFill/>
+          <a:ln/>
+        </p:spPr>
+        <p:txBody>
+          <a:bodyPr wrap="square" lIns="0" tIns="0" rIns="0" bIns="0" rtlCol="0" anchor="ctr"/>
+          <a:lstStyle/>
+          <a:p>
+            <a:pPr indent="0" marL="0">
+              <a:buNone/>
+            </a:pPr>
+            <a:r>
+              <a:rPr lang="en-US" sz="1100" b="1" spc="200" kern="0" dirty="0">
+                <a:solidFill>
+                  <a:srgbClr val="E09F3E"/>
+                </a:solidFill>
+              </a:rPr>
+              <a:t>PYTHON</a:t>
+            </a:r>
+            <a:endParaRPr lang="en-US" sz="1100" dirty="0"/>
+          </a:p>
+        </p:txBody>
+      </p:sp>
+      <p:sp>
+        <p:nvSpPr>
+          <p:cNvPr id="5" name="Text 3"/>
+          <p:cNvSpPr txBox="1"/>
+          <p:nvPr/>
+        </p:nvSpPr>
+        <p:spPr>
+          <a:xfrm>
+            <a:off x="777240" y="2194560"/>
+            <a:ext cx="6126480" cy="594360"/>
+          </a:xfrm>
+          <a:prstGeom prst="rect">
+            <a:avLst/>
+          </a:prstGeom>
+          <a:noFill/>
+          <a:ln/>
+        </p:spPr>
+        <p:txBody>
+          <a:bodyPr wrap="square" lIns="0" tIns="0" rIns="0" bIns="0" rtlCol="0" anchor="t"/>
+          <a:lstStyle/>
+          <a:p>
+            <a:pPr indent="0" marL="0">
+              <a:buNone/>
+            </a:pPr>
+            <a:r>
+              <a:rPr lang="en-US" sz="1600" dirty="0">
+                <a:solidFill>
+                  <a:srgbClr val="FFFFFF"/>
+                </a:solidFill>
+                <a:latin typeface="Courier New" pitchFamily="34" charset="0"/>
+                <a:ea typeface="Courier New" pitchFamily="34" charset="-122"/>
+                <a:cs typeface="Courier New" pitchFamily="34" charset="-120"/>
+              </a:rPr>
+              <a:t>capoluoghi = {"Lazio": "Roma",</a:t>
+            </a:r>
+            <a:endParaRPr lang="en-US" sz="1600" dirty="0"/>
+          </a:p>
+          <a:p>
+            <a:pPr indent="0" marL="0">
+              <a:buNone/>
+            </a:pPr>
+            <a:r>
+              <a:rPr lang="en-US" sz="1600" dirty="0">
+                <a:solidFill>
+                  <a:srgbClr val="FFFFFF"/>
+                </a:solidFill>
+                <a:latin typeface="Courier New" pitchFamily="34" charset="0"/>
+                <a:ea typeface="Courier New" pitchFamily="34" charset="-122"/>
+                <a:cs typeface="Courier New" pitchFamily="34" charset="-120"/>
+              </a:rPr>
+              <a:t>              "Veneto": "Venezia"}</a:t>
+            </a:r>
+            <a:endParaRPr lang="en-US" sz="1600" dirty="0"/>
+          </a:p>
+        </p:txBody>
+      </p:sp>
+      <p:sp>
+        <p:nvSpPr>
+          <p:cNvPr id="6" name="card-code"/>
+          <p:cNvSpPr/>
+          <p:nvPr/>
+        </p:nvSpPr>
+        <p:spPr>
+          <a:xfrm>
+            <a:off x="548640" y="3108960"/>
+            <a:ext cx="3200400" cy="1005840"/>
+          </a:xfrm>
+          <a:prstGeom prst="roundRect">
+            <a:avLst>
+              <a:gd name="adj" fmla="val 10909"/>
+            </a:avLst>
+          </a:prstGeom>
+          <a:solidFill>
+            <a:srgbClr val="1F2A30"/>
+          </a:solidFill>
+          <a:ln/>
+        </p:spPr>
+      </p:sp>
+      <p:sp>
+        <p:nvSpPr>
+          <p:cNvPr id="7" name="Text 5"/>
+          <p:cNvSpPr txBox="1"/>
+          <p:nvPr/>
+        </p:nvSpPr>
+        <p:spPr>
+          <a:xfrm>
+            <a:off x="777240" y="3246120"/>
+            <a:ext cx="1828800" cy="274320"/>
+          </a:xfrm>
+          <a:prstGeom prst="rect">
+            <a:avLst/>
+          </a:prstGeom>
+          <a:noFill/>
+          <a:ln/>
+        </p:spPr>
+        <p:txBody>
+          <a:bodyPr wrap="square" lIns="0" tIns="0" rIns="0" bIns="0" rtlCol="0" anchor="ctr"/>
+          <a:lstStyle/>
+          <a:p>
+            <a:pPr indent="0" marL="0">
+              <a:buNone/>
+            </a:pPr>
+            <a:r>
+              <a:rPr lang="en-US" sz="1100" b="1" spc="200" kern="0" dirty="0">
+                <a:solidFill>
+                  <a:srgbClr val="E09F3E"/>
+                </a:solidFill>
+              </a:rPr>
+              <a:t>PYTHON</a:t>
+            </a:r>
+            <a:endParaRPr lang="en-US" sz="1100" dirty="0"/>
+          </a:p>
+        </p:txBody>
+      </p:sp>
+      <p:sp>
+        <p:nvSpPr>
+          <p:cNvPr id="8" name="Text 6"/>
+          <p:cNvSpPr txBox="1"/>
+          <p:nvPr/>
+        </p:nvSpPr>
+        <p:spPr>
+          <a:xfrm>
+            <a:off x="777240" y="3566160"/>
+            <a:ext cx="2743200" cy="411480"/>
+          </a:xfrm>
+          <a:prstGeom prst="rect">
+            <a:avLst/>
+          </a:prstGeom>
+          <a:noFill/>
+          <a:ln/>
+        </p:spPr>
+        <p:txBody>
+          <a:bodyPr wrap="square" lIns="0" tIns="0" rIns="0" bIns="0" rtlCol="0" anchor="t"/>
+          <a:lstStyle/>
+          <a:p>
+            <a:pPr indent="0" marL="0">
+              <a:buNone/>
+            </a:pPr>
+            <a:r>
+              <a:rPr lang="en-US" sz="1600" dirty="0">
+                <a:solidFill>
+                  <a:srgbClr val="FFFFFF"/>
+                </a:solidFill>
+                <a:latin typeface="Courier New" pitchFamily="34" charset="0"/>
+                <a:ea typeface="Courier New" pitchFamily="34" charset="-122"/>
+                <a:cs typeface="Courier New" pitchFamily="34" charset="-120"/>
+              </a:rPr>
+              <a:t>capoluoghi["Lazio"]</a:t>
+            </a:r>
+            <a:endParaRPr lang="en-US" sz="1600" dirty="0"/>
+          </a:p>
+        </p:txBody>
+      </p:sp>
+      <p:sp>
+        <p:nvSpPr>
+          <p:cNvPr id="9" name="card-out"/>
+          <p:cNvSpPr/>
+          <p:nvPr/>
+        </p:nvSpPr>
+        <p:spPr>
+          <a:xfrm>
+            <a:off x="3931920" y="3108960"/>
+            <a:ext cx="3200400" cy="1005840"/>
+          </a:xfrm>
+          <a:prstGeom prst="roundRect">
+            <a:avLst>
+              <a:gd name="adj" fmla="val 10909"/>
+            </a:avLst>
+          </a:prstGeom>
+          <a:solidFill>
+            <a:srgbClr val="EEF3F4"/>
+          </a:solidFill>
+          <a:ln/>
+        </p:spPr>
+      </p:sp>
+      <p:sp>
+        <p:nvSpPr>
+          <p:cNvPr id="10" name="Text 8"/>
+          <p:cNvSpPr txBox="1"/>
+          <p:nvPr/>
+        </p:nvSpPr>
+        <p:spPr>
+          <a:xfrm>
+            <a:off x="4160520" y="3246120"/>
+            <a:ext cx="1828800" cy="274320"/>
+          </a:xfrm>
+          <a:prstGeom prst="rect">
+            <a:avLst/>
+          </a:prstGeom>
+          <a:noFill/>
+          <a:ln/>
+        </p:spPr>
+        <p:txBody>
+          <a:bodyPr wrap="square" lIns="0" tIns="0" rIns="0" bIns="0" rtlCol="0" anchor="ctr"/>
+          <a:lstStyle/>
+          <a:p>
+            <a:pPr indent="0" marL="0">
+              <a:buNone/>
+            </a:pPr>
+            <a:r>
+              <a:rPr lang="en-US" sz="1100" b="1" spc="200" kern="0" dirty="0">
+                <a:solidFill>
+                  <a:srgbClr val="5C6F7B"/>
+                </a:solidFill>
+              </a:rPr>
+              <a:t>OUTPUT</a:t>
+            </a:r>
+            <a:endParaRPr lang="en-US" sz="1100" dirty="0"/>
+          </a:p>
+        </p:txBody>
+      </p:sp>
+      <p:sp>
+        <p:nvSpPr>
+          <p:cNvPr id="11" name="Text 9"/>
+          <p:cNvSpPr txBox="1"/>
+          <p:nvPr/>
+        </p:nvSpPr>
+        <p:spPr>
+          <a:xfrm>
+            <a:off x="4160520" y="3566160"/>
+            <a:ext cx="2743200" cy="411480"/>
+          </a:xfrm>
+          <a:prstGeom prst="rect">
+            <a:avLst/>
+          </a:prstGeom>
+          <a:noFill/>
+          <a:ln/>
+        </p:spPr>
+        <p:txBody>
+          <a:bodyPr wrap="square" lIns="0" tIns="0" rIns="0" bIns="0" rtlCol="0" anchor="t"/>
+          <a:lstStyle/>
+          <a:p>
+            <a:pPr indent="0" marL="0">
+              <a:buNone/>
+            </a:pPr>
+            <a:r>
+              <a:rPr lang="en-US" sz="1600" dirty="0">
+                <a:solidFill>
+                  <a:srgbClr val="1F2A30"/>
+                </a:solidFill>
+                <a:latin typeface="Courier New" pitchFamily="34" charset="0"/>
+                <a:ea typeface="Courier New" pitchFamily="34" charset="-122"/>
+                <a:cs typeface="Courier New" pitchFamily="34" charset="-120"/>
+              </a:rPr>
+              <a:t>"Roma"</a:t>
+            </a:r>
+            <a:endParaRPr lang="en-US" sz="1600" dirty="0"/>
+          </a:p>
+        </p:txBody>
+      </p:sp>
+      <p:sp>
+        <p:nvSpPr>
+          <p:cNvPr id="12" name="card-code"/>
+          <p:cNvSpPr/>
+          <p:nvPr/>
+        </p:nvSpPr>
+        <p:spPr>
+          <a:xfrm>
+            <a:off x="548640" y="4343400"/>
             <a:ext cx="6583680" cy="1371600"/>
           </a:xfrm>
           <a:prstGeom prst="roundRect">
@@ -4734,13 +5247,13 @@
       </p:sp>
       <p:sp>
         <p:nvSpPr>
-          <p:cNvPr id="4" name="Text 2"/>
+          <p:cNvPr id="13" name="Text 11"/>
           <p:cNvSpPr txBox="1"/>
           <p:nvPr/>
         </p:nvSpPr>
         <p:spPr>
           <a:xfrm>
-            <a:off x="777240" y="1874520"/>
+            <a:off x="777240" y="4480560"/>
             <a:ext cx="1828800" cy="274320"/>
           </a:xfrm>
           <a:prstGeom prst="rect">
@@ -4770,13 +5283,13 @@
       </p:sp>
       <p:sp>
         <p:nvSpPr>
-          <p:cNvPr id="5" name="Text 3"/>
+          <p:cNvPr id="14" name="Text 12"/>
           <p:cNvSpPr txBox="1"/>
           <p:nvPr/>
         </p:nvSpPr>
         <p:spPr>
           <a:xfrm>
-            <a:off x="777240" y="2194560"/>
+            <a:off x="777240" y="4800600"/>
             <a:ext cx="6126480" cy="777240"/>
           </a:xfrm>
           <a:prstGeom prst="rect">
@@ -4793,7 +5306,7 @@
               <a:buNone/>
             </a:pPr>
             <a:r>
-              <a:rPr lang="en-US" sz="2000" dirty="0">
+              <a:rPr lang="en-US" sz="1500" dirty="0">
                 <a:solidFill>
                   <a:srgbClr val="FFFFFF"/>
                 </a:solidFill>
@@ -4801,254 +5314,120 @@
                 <a:ea typeface="Courier New" pitchFamily="34" charset="-122"/>
                 <a:cs typeface="Courier New" pitchFamily="34" charset="-120"/>
               </a:rPr>
-              <a:t>pd.to_numeric(col, errors="coerce")</a:t>
-            </a:r>
-            <a:endParaRPr lang="en-US" sz="2000" dirty="0"/>
-          </a:p>
-        </p:txBody>
-      </p:sp>
-      <p:sp>
-        <p:nvSpPr>
-          <p:cNvPr id="6" name="card-out"/>
-          <p:cNvSpPr/>
-          <p:nvPr/>
-        </p:nvSpPr>
-        <p:spPr>
-          <a:xfrm>
-            <a:off x="548640" y="3337560"/>
-            <a:ext cx="6583680" cy="1737360"/>
-          </a:xfrm>
-          <a:prstGeom prst="roundRect">
-            <a:avLst>
-              <a:gd name="adj" fmla="val 6316"/>
-            </a:avLst>
-          </a:prstGeom>
-          <a:solidFill>
-            <a:srgbClr val="EEF3F4"/>
-          </a:solidFill>
-          <a:ln/>
-        </p:spPr>
-      </p:sp>
-      <p:sp>
-        <p:nvSpPr>
-          <p:cNvPr id="7" name="Text 5"/>
-          <p:cNvSpPr txBox="1"/>
-          <p:nvPr/>
-        </p:nvSpPr>
-        <p:spPr>
-          <a:xfrm>
-            <a:off x="777240" y="3474720"/>
-            <a:ext cx="1828800" cy="274320"/>
-          </a:xfrm>
-          <a:prstGeom prst="rect">
-            <a:avLst/>
-          </a:prstGeom>
-          <a:noFill/>
-          <a:ln/>
-        </p:spPr>
-        <p:txBody>
-          <a:bodyPr wrap="square" lIns="0" tIns="0" rIns="0" bIns="0" rtlCol="0" anchor="ctr"/>
-          <a:lstStyle/>
-          <a:p>
-            <a:pPr indent="0" marL="0">
-              <a:buNone/>
-            </a:pPr>
-            <a:r>
-              <a:rPr lang="en-US" sz="1100" b="1" spc="200" kern="0" dirty="0">
-                <a:solidFill>
-                  <a:srgbClr val="5C6F7B"/>
-                </a:solidFill>
-              </a:rPr>
-              <a:t>OUTPUT</a:t>
-            </a:r>
-            <a:endParaRPr lang="en-US" sz="1100" dirty="0"/>
-          </a:p>
-        </p:txBody>
-      </p:sp>
-      <p:sp>
-        <p:nvSpPr>
-          <p:cNvPr id="8" name="Text 6"/>
-          <p:cNvSpPr txBox="1"/>
-          <p:nvPr/>
-        </p:nvSpPr>
-        <p:spPr>
-          <a:xfrm>
-            <a:off x="777240" y="3794760"/>
-            <a:ext cx="6126480" cy="1143000"/>
-          </a:xfrm>
-          <a:prstGeom prst="rect">
-            <a:avLst/>
-          </a:prstGeom>
-          <a:noFill/>
-          <a:ln/>
-        </p:spPr>
-        <p:txBody>
-          <a:bodyPr wrap="square" lIns="0" tIns="0" rIns="0" bIns="0" rtlCol="0" anchor="t"/>
-          <a:lstStyle/>
-          <a:p>
-            <a:pPr indent="0" marL="0">
-              <a:buNone/>
-            </a:pPr>
-            <a:r>
-              <a:rPr lang="en-US" sz="2000" dirty="0">
-                <a:solidFill>
-                  <a:srgbClr val="1F2A30"/>
+              <a:t>df["citta"].replace({"Milan": "Milano",</a:t>
+            </a:r>
+            <a:endParaRPr lang="en-US" sz="1500" dirty="0"/>
+          </a:p>
+          <a:p>
+            <a:pPr indent="0" marL="0">
+              <a:buNone/>
+            </a:pPr>
+            <a:r>
+              <a:rPr lang="en-US" sz="1500" dirty="0">
+                <a:solidFill>
+                  <a:srgbClr val="FFFFFF"/>
                 </a:solidFill>
                 <a:latin typeface="Courier New" pitchFamily="34" charset="0"/>
                 <a:ea typeface="Courier New" pitchFamily="34" charset="-122"/>
                 <a:cs typeface="Courier New" pitchFamily="34" charset="-120"/>
               </a:rPr>
-              <a:t>"12.5"   →  12.5</a:t>
-            </a:r>
-            <a:endParaRPr lang="en-US" sz="2000" dirty="0"/>
-          </a:p>
-          <a:p>
-            <a:pPr indent="0" marL="0">
-              <a:buNone/>
-            </a:pPr>
-            <a:r>
-              <a:rPr lang="en-US" sz="2000" dirty="0">
+              <a:t>                     "Rome": "Roma"})</a:t>
+            </a:r>
+            <a:endParaRPr lang="en-US" sz="1500" dirty="0"/>
+          </a:p>
+        </p:txBody>
+      </p:sp>
+      <p:sp>
+        <p:nvSpPr>
+          <p:cNvPr id="15" name="Text 13"/>
+          <p:cNvSpPr txBox="1"/>
+          <p:nvPr/>
+        </p:nvSpPr>
+        <p:spPr>
+          <a:xfrm>
+            <a:off x="7498080" y="1828800"/>
+            <a:ext cx="4114800" cy="3931920"/>
+          </a:xfrm>
+          <a:prstGeom prst="rect">
+            <a:avLst/>
+          </a:prstGeom>
+          <a:noFill/>
+          <a:ln/>
+        </p:spPr>
+        <p:txBody>
+          <a:bodyPr wrap="square" lIns="0" tIns="0" rIns="0" bIns="0" rtlCol="0" anchor="t"/>
+          <a:lstStyle/>
+          <a:p>
+            <a:pPr marL="342900" indent="-342900">
+              <a:spcAft>
+                <a:spcPts val="1000"/>
+              </a:spcAft>
+              <a:buSzPct val="100000"/>
+              <a:buChar char="•"/>
+            </a:pPr>
+            <a:r>
+              <a:rPr lang="en-US" sz="1800" dirty="0">
                 <a:solidFill>
                   <a:srgbClr val="1F2A30"/>
                 </a:solidFill>
-                <a:latin typeface="Courier New" pitchFamily="34" charset="0"/>
-                <a:ea typeface="Courier New" pitchFamily="34" charset="-122"/>
-                <a:cs typeface="Courier New" pitchFamily="34" charset="-120"/>
-              </a:rPr>
-              <a:t>"abc"    →  NaN</a:t>
-            </a:r>
-            <a:endParaRPr lang="en-US" sz="2000" dirty="0"/>
-          </a:p>
-          <a:p>
-            <a:pPr indent="0" marL="0">
-              <a:buNone/>
-            </a:pPr>
-            <a:r>
-              <a:rPr lang="en-US" sz="2000" dirty="0">
+              </a:rPr>
+              <a:t>Tra parentesi graffe, coppie chiave: valore</a:t>
+            </a:r>
+            <a:endParaRPr lang="en-US" sz="1800" dirty="0"/>
+          </a:p>
+          <a:p>
+            <a:pPr marL="342900" indent="-342900">
+              <a:spcAft>
+                <a:spcPts val="1000"/>
+              </a:spcAft>
+              <a:buSzPct val="100000"/>
+              <a:buChar char="•"/>
+            </a:pPr>
+            <a:r>
+              <a:rPr lang="en-US" sz="1800" dirty="0">
                 <a:solidFill>
                   <a:srgbClr val="1F2A30"/>
                 </a:solidFill>
-                <a:latin typeface="Courier New" pitchFamily="34" charset="0"/>
-                <a:ea typeface="Courier New" pitchFamily="34" charset="-122"/>
-                <a:cs typeface="Courier New" pitchFamily="34" charset="-120"/>
-              </a:rPr>
-              <a:t>"12,5"   →  NaN</a:t>
-            </a:r>
-            <a:endParaRPr lang="en-US" sz="2000" dirty="0"/>
-          </a:p>
-        </p:txBody>
-      </p:sp>
-      <p:sp>
-        <p:nvSpPr>
-          <p:cNvPr id="9" name="Shape 7"/>
-          <p:cNvSpPr/>
-          <p:nvPr/>
-        </p:nvSpPr>
-        <p:spPr>
-          <a:xfrm>
-            <a:off x="7589520" y="1737360"/>
-            <a:ext cx="4023360" cy="3337560"/>
-          </a:xfrm>
-          <a:prstGeom prst="roundRect">
-            <a:avLst>
-              <a:gd name="adj" fmla="val 3288"/>
-            </a:avLst>
-          </a:prstGeom>
-          <a:solidFill>
-            <a:srgbClr val="EEF3F4"/>
-          </a:solidFill>
-          <a:ln/>
-        </p:spPr>
-      </p:sp>
-      <p:sp>
-        <p:nvSpPr>
-          <p:cNvPr id="10" name="Text 8"/>
-          <p:cNvSpPr txBox="1"/>
-          <p:nvPr/>
-        </p:nvSpPr>
-        <p:spPr>
-          <a:xfrm>
-            <a:off x="7863840" y="1965960"/>
-            <a:ext cx="3474720" cy="365760"/>
-          </a:xfrm>
-          <a:prstGeom prst="rect">
-            <a:avLst/>
-          </a:prstGeom>
-          <a:noFill/>
-          <a:ln/>
-        </p:spPr>
-        <p:txBody>
-          <a:bodyPr wrap="square" lIns="0" tIns="0" rIns="0" bIns="0" rtlCol="0" anchor="ctr"/>
-          <a:lstStyle/>
-          <a:p>
-            <a:pPr indent="0" marL="0">
-              <a:buNone/>
-            </a:pPr>
-            <a:r>
-              <a:rPr lang="en-US" sz="1300" b="1" spc="200" kern="0" dirty="0">
-                <a:solidFill>
-                  <a:srgbClr val="8F5308"/>
-                </a:solidFill>
-              </a:rPr>
-              <a:t>ATTENZIONE</a:t>
-            </a:r>
-            <a:endParaRPr lang="en-US" sz="1300" dirty="0"/>
-          </a:p>
-        </p:txBody>
-      </p:sp>
-      <p:sp>
-        <p:nvSpPr>
-          <p:cNvPr id="11" name="Text 9"/>
-          <p:cNvSpPr txBox="1"/>
-          <p:nvPr/>
-        </p:nvSpPr>
-        <p:spPr>
-          <a:xfrm>
-            <a:off x="7863840" y="2423160"/>
-            <a:ext cx="3474720" cy="2468880"/>
-          </a:xfrm>
-          <a:prstGeom prst="rect">
-            <a:avLst/>
-          </a:prstGeom>
-          <a:noFill/>
-          <a:ln/>
-        </p:spPr>
-        <p:txBody>
-          <a:bodyPr wrap="square" lIns="0" tIns="0" rIns="0" bIns="0" rtlCol="0" anchor="t"/>
-          <a:lstStyle/>
-          <a:p>
-            <a:pPr indent="0" marL="0">
-              <a:buNone/>
-            </a:pPr>
-            <a:r>
-              <a:rPr lang="en-US" sz="1900" dirty="0">
+              </a:rPr>
+              <a:t>Con la chiave tra parentesi quadre leggi il valore</a:t>
+            </a:r>
+            <a:endParaRPr lang="en-US" sz="1800" dirty="0"/>
+          </a:p>
+          <a:p>
+            <a:pPr marL="342900" indent="-342900">
+              <a:spcAft>
+                <a:spcPts val="1000"/>
+              </a:spcAft>
+              <a:buSzPct val="100000"/>
+              <a:buChar char="•"/>
+            </a:pPr>
+            <a:r>
+              <a:rPr lang="en-US" sz="1800" dirty="0">
                 <a:solidFill>
                   <a:srgbClr val="1F2A30"/>
                 </a:solidFill>
               </a:rPr>
-              <a:t>Quello che non si converte diventa un valore mancante. Senza errori.</a:t>
-            </a:r>
-            <a:endParaRPr lang="en-US" sz="1900" dirty="0"/>
-          </a:p>
-          <a:p>
-            <a:pPr indent="0" marL="0">
-              <a:buNone/>
-            </a:pPr>
-            <a:endParaRPr lang="en-US" sz="1900" dirty="0"/>
-          </a:p>
-          <a:p>
-            <a:pPr indent="0" marL="0">
-              <a:buNone/>
-            </a:pPr>
-            <a:r>
-              <a:rPr lang="en-US" sz="1900" dirty="0">
-                <a:solidFill>
-                  <a:srgbClr val="1F2A30"/>
-                </a:solidFill>
-              </a:rPr>
-              <a:t>Dopo ogni conversione: conta i mancanti.</a:t>
-            </a:r>
-            <a:endParaRPr lang="en-US" sz="1900" dirty="0"/>
+              <a:t>Come un vocabolario: cerchi la parola, trovi la definizione</a:t>
+            </a:r>
+            <a:endParaRPr lang="en-US" sz="1800" dirty="0"/>
+          </a:p>
+          <a:p>
+            <a:pPr marL="342900" indent="-342900">
+              <a:spcAft>
+                <a:spcPts val="1000"/>
+              </a:spcAft>
+              <a:buSzPct val="100000"/>
+              <a:buChar char="•"/>
+            </a:pPr>
+            <a:r>
+              <a:rPr lang="en-US" sz="1800" b="1" dirty="0">
+                <a:solidFill>
+                  <a:srgbClr val="0F4C5C"/>
+                </a:solidFill>
+              </a:rPr>
+              <a:t>replace usa un dizionario come tabella di correzioni: sbagliato → giusto</a:t>
+            </a:r>
+            <a:endParaRPr lang="en-US" sz="1800" dirty="0"/>
           </a:p>
         </p:txBody>
       </p:sp>
@@ -5154,7 +5533,7 @@
                   <a:srgbClr val="0F4C5C"/>
                 </a:solidFill>
               </a:rPr>
-              <a:t>Correggere solo alcune righe</a:t>
+              <a:t>Da testo a numero</a:t>
             </a:r>
             <a:endParaRPr lang="en-US" sz="3600" dirty="0"/>
           </a:p>
@@ -5169,6 +5548,103 @@
         <p:spPr>
           <a:xfrm>
             <a:off x="548640" y="1737360"/>
+            <a:ext cx="6583680" cy="1371600"/>
+          </a:xfrm>
+          <a:prstGeom prst="roundRect">
+            <a:avLst>
+              <a:gd name="adj" fmla="val 8000"/>
+            </a:avLst>
+          </a:prstGeom>
+          <a:solidFill>
+            <a:srgbClr val="1F2A30"/>
+          </a:solidFill>
+          <a:ln/>
+        </p:spPr>
+      </p:sp>
+      <p:sp>
+        <p:nvSpPr>
+          <p:cNvPr id="4" name="Text 2"/>
+          <p:cNvSpPr txBox="1"/>
+          <p:nvPr/>
+        </p:nvSpPr>
+        <p:spPr>
+          <a:xfrm>
+            <a:off x="777240" y="1874520"/>
+            <a:ext cx="1828800" cy="274320"/>
+          </a:xfrm>
+          <a:prstGeom prst="rect">
+            <a:avLst/>
+          </a:prstGeom>
+          <a:noFill/>
+          <a:ln/>
+        </p:spPr>
+        <p:txBody>
+          <a:bodyPr wrap="square" lIns="0" tIns="0" rIns="0" bIns="0" rtlCol="0" anchor="ctr"/>
+          <a:lstStyle/>
+          <a:p>
+            <a:pPr indent="0" marL="0">
+              <a:buNone/>
+            </a:pPr>
+            <a:r>
+              <a:rPr lang="en-US" sz="1100" b="1" spc="200" kern="0" dirty="0">
+                <a:solidFill>
+                  <a:srgbClr val="E09F3E"/>
+                </a:solidFill>
+              </a:rPr>
+              <a:t>PYTHON</a:t>
+            </a:r>
+            <a:endParaRPr lang="en-US" sz="1100" dirty="0"/>
+          </a:p>
+        </p:txBody>
+      </p:sp>
+      <p:sp>
+        <p:nvSpPr>
+          <p:cNvPr id="5" name="Text 3"/>
+          <p:cNvSpPr txBox="1"/>
+          <p:nvPr/>
+        </p:nvSpPr>
+        <p:spPr>
+          <a:xfrm>
+            <a:off x="777240" y="2194560"/>
+            <a:ext cx="6126480" cy="777240"/>
+          </a:xfrm>
+          <a:prstGeom prst="rect">
+            <a:avLst/>
+          </a:prstGeom>
+          <a:noFill/>
+          <a:ln/>
+        </p:spPr>
+        <p:txBody>
+          <a:bodyPr wrap="square" lIns="0" tIns="0" rIns="0" bIns="0" rtlCol="0" anchor="t"/>
+          <a:lstStyle/>
+          <a:p>
+            <a:pPr indent="0" marL="0">
+              <a:buNone/>
+            </a:pPr>
+            <a:r>
+              <a:rPr lang="en-US" sz="2000" dirty="0">
+                <a:solidFill>
+                  <a:srgbClr val="FFFFFF"/>
+                </a:solidFill>
+                <a:latin typeface="Courier New" pitchFamily="34" charset="0"/>
+                <a:ea typeface="Courier New" pitchFamily="34" charset="-122"/>
+                <a:cs typeface="Courier New" pitchFamily="34" charset="-120"/>
+              </a:rPr>
+              <a:t>pd.to_numeric(col, errors="coerce")</a:t>
+            </a:r>
+            <a:endParaRPr lang="en-US" sz="2000" dirty="0"/>
+          </a:p>
+        </p:txBody>
+      </p:sp>
+      <p:sp>
+        <p:nvSpPr>
+          <p:cNvPr id="6" name="card-out"/>
+          <p:cNvSpPr/>
+          <p:nvPr/>
+        </p:nvSpPr>
+        <p:spPr>
+          <a:xfrm>
+            <a:off x="548640" y="3337560"/>
             <a:ext cx="6583680" cy="1737360"/>
           </a:xfrm>
           <a:prstGeom prst="roundRect">
@@ -5177,20 +5653,20 @@
             </a:avLst>
           </a:prstGeom>
           <a:solidFill>
-            <a:srgbClr val="1F2A30"/>
+            <a:srgbClr val="EEF3F4"/>
           </a:solidFill>
           <a:ln/>
         </p:spPr>
       </p:sp>
       <p:sp>
         <p:nvSpPr>
-          <p:cNvPr id="4" name="Text 2"/>
+          <p:cNvPr id="7" name="Text 5"/>
           <p:cNvSpPr txBox="1"/>
           <p:nvPr/>
         </p:nvSpPr>
         <p:spPr>
           <a:xfrm>
-            <a:off x="777240" y="1874520"/>
+            <a:off x="777240" y="3474720"/>
             <a:ext cx="1828800" cy="274320"/>
           </a:xfrm>
           <a:prstGeom prst="rect">
@@ -5209,10 +5685,10 @@
             <a:r>
               <a:rPr lang="en-US" sz="1100" b="1" spc="200" kern="0" dirty="0">
                 <a:solidFill>
-                  <a:srgbClr val="E09F3E"/>
-                </a:solidFill>
-              </a:rPr>
-              <a:t>PYTHON</a:t>
+                  <a:srgbClr val="5C6F7B"/>
+                </a:solidFill>
+              </a:rPr>
+              <a:t>OUTPUT</a:t>
             </a:r>
             <a:endParaRPr lang="en-US" sz="1100" dirty="0"/>
           </a:p>
@@ -5220,13 +5696,13 @@
       </p:sp>
       <p:sp>
         <p:nvSpPr>
-          <p:cNvPr id="5" name="Text 3"/>
+          <p:cNvPr id="8" name="Text 6"/>
           <p:cNvSpPr txBox="1"/>
           <p:nvPr/>
         </p:nvSpPr>
         <p:spPr>
           <a:xfrm>
-            <a:off x="777240" y="2194560"/>
+            <a:off x="777240" y="3794760"/>
             <a:ext cx="6126480" cy="1143000"/>
           </a:xfrm>
           <a:prstGeom prst="rect">
@@ -5243,155 +5719,79 @@
               <a:buNone/>
             </a:pPr>
             <a:r>
-              <a:rPr lang="en-US" sz="1800" dirty="0">
-                <a:solidFill>
-                  <a:srgbClr val="FFFFFF"/>
+              <a:rPr lang="en-US" sz="2000" dirty="0">
+                <a:solidFill>
+                  <a:srgbClr val="1F2A30"/>
                 </a:solidFill>
                 <a:latin typeface="Courier New" pitchFamily="34" charset="0"/>
                 <a:ea typeface="Courier New" pitchFamily="34" charset="-122"/>
                 <a:cs typeface="Courier New" pitchFamily="34" charset="-120"/>
               </a:rPr>
-              <a:t>negativi = df["prezzo"] &lt; 0</a:t>
-            </a:r>
-            <a:endParaRPr lang="en-US" sz="1800" dirty="0"/>
-          </a:p>
-          <a:p>
-            <a:pPr indent="0" marL="0">
-              <a:buNone/>
-            </a:pPr>
-            <a:r>
-              <a:rPr lang="en-US" sz="1800" dirty="0">
-                <a:solidFill>
-                  <a:srgbClr val="FFFFFF"/>
+              <a:t>"12.5"   →  12.5</a:t>
+            </a:r>
+            <a:endParaRPr lang="en-US" sz="2000" dirty="0"/>
+          </a:p>
+          <a:p>
+            <a:pPr indent="0" marL="0">
+              <a:buNone/>
+            </a:pPr>
+            <a:r>
+              <a:rPr lang="en-US" sz="2000" dirty="0">
+                <a:solidFill>
+                  <a:srgbClr val="1F2A30"/>
                 </a:solidFill>
                 <a:latin typeface="Courier New" pitchFamily="34" charset="0"/>
                 <a:ea typeface="Courier New" pitchFamily="34" charset="-122"/>
                 <a:cs typeface="Courier New" pitchFamily="34" charset="-120"/>
               </a:rPr>
-              <a:t>print(negativi.sum())</a:t>
-            </a:r>
-            <a:endParaRPr lang="en-US" sz="1800" dirty="0"/>
-          </a:p>
-          <a:p>
-            <a:pPr indent="0" marL="0">
-              <a:buNone/>
-            </a:pPr>
-            <a:r>
-              <a:rPr lang="en-US" sz="1800" dirty="0">
-                <a:solidFill>
-                  <a:srgbClr val="FFFFFF"/>
+              <a:t>"abc"    →  NaN</a:t>
+            </a:r>
+            <a:endParaRPr lang="en-US" sz="2000" dirty="0"/>
+          </a:p>
+          <a:p>
+            <a:pPr indent="0" marL="0">
+              <a:buNone/>
+            </a:pPr>
+            <a:r>
+              <a:rPr lang="en-US" sz="2000" dirty="0">
+                <a:solidFill>
+                  <a:srgbClr val="1F2A30"/>
                 </a:solidFill>
                 <a:latin typeface="Courier New" pitchFamily="34" charset="0"/>
                 <a:ea typeface="Courier New" pitchFamily="34" charset="-122"/>
                 <a:cs typeface="Courier New" pitchFamily="34" charset="-120"/>
               </a:rPr>
-              <a:t>df.loc[negativi, "prezzo"] = None</a:t>
-            </a:r>
-            <a:endParaRPr lang="en-US" sz="1800" dirty="0"/>
-          </a:p>
-        </p:txBody>
-      </p:sp>
-      <p:sp>
-        <p:nvSpPr>
-          <p:cNvPr id="6" name="Text 4"/>
-          <p:cNvSpPr txBox="1"/>
-          <p:nvPr/>
-        </p:nvSpPr>
-        <p:spPr>
-          <a:xfrm>
-            <a:off x="548640" y="3749040"/>
-            <a:ext cx="6583680" cy="1828800"/>
-          </a:xfrm>
-          <a:prstGeom prst="rect">
-            <a:avLst/>
-          </a:prstGeom>
-          <a:noFill/>
-          <a:ln/>
-        </p:spPr>
-        <p:txBody>
-          <a:bodyPr wrap="square" lIns="0" tIns="0" rIns="0" bIns="0" rtlCol="0" anchor="t"/>
-          <a:lstStyle/>
-          <a:p>
-            <a:pPr marL="342900" indent="-342900">
-              <a:spcAft>
-                <a:spcPts val="1000"/>
-              </a:spcAft>
-              <a:buSzPct val="100000"/>
-              <a:buChar char="•"/>
-            </a:pPr>
-            <a:r>
-              <a:rPr lang="en-US" sz="1800" dirty="0">
-                <a:solidFill>
-                  <a:srgbClr val="1F2A30"/>
-                </a:solidFill>
-              </a:rPr>
-              <a:t>Una condizione è una colonna di True e False</a:t>
-            </a:r>
-            <a:endParaRPr lang="en-US" sz="1800" dirty="0"/>
-          </a:p>
-          <a:p>
-            <a:pPr marL="342900" indent="-342900">
-              <a:spcAft>
-                <a:spcPts val="1000"/>
-              </a:spcAft>
-              <a:buSzPct val="100000"/>
-              <a:buChar char="•"/>
-            </a:pPr>
-            <a:r>
-              <a:rPr lang="en-US" sz="1800" dirty="0">
-                <a:solidFill>
-                  <a:srgbClr val="1F2A30"/>
-                </a:solidFill>
-              </a:rPr>
-              <a:t>.sum() conta quante righe la rispettano</a:t>
-            </a:r>
-            <a:endParaRPr lang="en-US" sz="1800" dirty="0"/>
-          </a:p>
-          <a:p>
-            <a:pPr marL="342900" indent="-342900">
-              <a:spcAft>
-                <a:spcPts val="1000"/>
-              </a:spcAft>
-              <a:buSzPct val="100000"/>
-              <a:buChar char="•"/>
-            </a:pPr>
-            <a:r>
-              <a:rPr lang="en-US" sz="1800" dirty="0">
-                <a:solidFill>
-                  <a:srgbClr val="1F2A30"/>
-                </a:solidFill>
-              </a:rPr>
-              <a:t>.loc[righe, colonna] = valore</a:t>
-            </a:r>
-            <a:endParaRPr lang="en-US" sz="1800" dirty="0"/>
-          </a:p>
-        </p:txBody>
-      </p:sp>
-      <p:sp>
-        <p:nvSpPr>
-          <p:cNvPr id="7" name="Shape 5"/>
+              <a:t>"12,5"   →  NaN</a:t>
+            </a:r>
+            <a:endParaRPr lang="en-US" sz="2000" dirty="0"/>
+          </a:p>
+        </p:txBody>
+      </p:sp>
+      <p:sp>
+        <p:nvSpPr>
+          <p:cNvPr id="9" name="Shape 7"/>
           <p:cNvSpPr/>
           <p:nvPr/>
         </p:nvSpPr>
         <p:spPr>
           <a:xfrm>
             <a:off x="7589520" y="1737360"/>
-            <a:ext cx="4023360" cy="3840480"/>
+            <a:ext cx="4023360" cy="3337560"/>
           </a:xfrm>
           <a:prstGeom prst="roundRect">
             <a:avLst>
-              <a:gd name="adj" fmla="val 2857"/>
+              <a:gd name="adj" fmla="val 3288"/>
             </a:avLst>
           </a:prstGeom>
           <a:solidFill>
-            <a:srgbClr val="0F4C5C"/>
+            <a:srgbClr val="EEF3F4"/>
           </a:solidFill>
           <a:ln/>
         </p:spPr>
       </p:sp>
       <p:sp>
         <p:nvSpPr>
-          <p:cNvPr id="8" name="Text 6"/>
+          <p:cNvPr id="10" name="Text 8"/>
           <p:cNvSpPr txBox="1"/>
           <p:nvPr/>
         </p:nvSpPr>
@@ -5416,10 +5816,10 @@
             <a:r>
               <a:rPr lang="en-US" sz="1300" b="1" spc="200" kern="0" dirty="0">
                 <a:solidFill>
-                  <a:srgbClr val="F4C06E"/>
-                </a:solidFill>
-              </a:rPr>
-              <a:t>MANCANTE NON È ZERO</a:t>
+                  <a:srgbClr val="8F5308"/>
+                </a:solidFill>
+              </a:rPr>
+              <a:t>ATTENZIONE</a:t>
             </a:r>
             <a:endParaRPr lang="en-US" sz="1300" dirty="0"/>
           </a:p>
@@ -5427,14 +5827,14 @@
       </p:sp>
       <p:sp>
         <p:nvSpPr>
-          <p:cNvPr id="9" name="Text 7"/>
+          <p:cNvPr id="11" name="Text 9"/>
           <p:cNvSpPr txBox="1"/>
           <p:nvPr/>
         </p:nvSpPr>
         <p:spPr>
           <a:xfrm>
-            <a:off x="7863840" y="2468880"/>
-            <a:ext cx="3474720" cy="2926080"/>
+            <a:off x="7863840" y="2423160"/>
+            <a:ext cx="3474720" cy="2468880"/>
           </a:xfrm>
           <a:prstGeom prst="rect">
             <a:avLst/>
@@ -5447,60 +5847,37 @@
           <a:lstStyle/>
           <a:p>
             <a:pPr indent="0" marL="0">
-              <a:spcAft>
-                <a:spcPts val="1200"/>
-              </a:spcAft>
-              <a:buNone/>
-            </a:pPr>
-            <a:r>
-              <a:rPr lang="en-US" sz="2000" dirty="0">
-                <a:solidFill>
-                  <a:srgbClr val="FFFFFF"/>
-                </a:solidFill>
-              </a:rPr>
-              <a:t>Media di 10, ?, 20</a:t>
-            </a:r>
-            <a:endParaRPr lang="en-US" sz="2000" dirty="0"/>
-          </a:p>
-          <a:p>
-            <a:pPr indent="0" marL="0">
-              <a:spcAft>
-                <a:spcPts val="1200"/>
-              </a:spcAft>
-              <a:buNone/>
-            </a:pPr>
-            <a:r>
-              <a:rPr lang="en-US" sz="2000" dirty="0">
-                <a:solidFill>
-                  <a:srgbClr val="FFFFFF"/>
-                </a:solidFill>
-                <a:latin typeface="Courier New" pitchFamily="34" charset="0"/>
-                <a:ea typeface="Courier New" pitchFamily="34" charset="-122"/>
-                <a:cs typeface="Courier New" pitchFamily="34" charset="-120"/>
-              </a:rPr>
-              <a:t>con il mancante: 15</a:t>
-            </a:r>
-            <a:endParaRPr lang="en-US" sz="2000" dirty="0"/>
-          </a:p>
-          <a:p>
-            <a:pPr indent="0" marL="0">
-              <a:spcAft>
-                <a:spcPts val="1200"/>
-              </a:spcAft>
-              <a:buNone/>
-            </a:pPr>
-            <a:r>
-              <a:rPr lang="en-US" sz="2000" dirty="0">
-                <a:solidFill>
-                  <a:srgbClr val="FFFFFF"/>
-                </a:solidFill>
-                <a:latin typeface="Courier New" pitchFamily="34" charset="0"/>
-                <a:ea typeface="Courier New" pitchFamily="34" charset="-122"/>
-                <a:cs typeface="Courier New" pitchFamily="34" charset="-120"/>
-              </a:rPr>
-              <a:t>con lo 0:       10</a:t>
-            </a:r>
-            <a:endParaRPr lang="en-US" sz="2000" dirty="0"/>
+              <a:buNone/>
+            </a:pPr>
+            <a:r>
+              <a:rPr lang="en-US" sz="1900" dirty="0">
+                <a:solidFill>
+                  <a:srgbClr val="1F2A30"/>
+                </a:solidFill>
+              </a:rPr>
+              <a:t>Quello che non si converte diventa un valore mancante. Senza errori.</a:t>
+            </a:r>
+            <a:endParaRPr lang="en-US" sz="1900" dirty="0"/>
+          </a:p>
+          <a:p>
+            <a:pPr indent="0" marL="0">
+              <a:buNone/>
+            </a:pPr>
+            <a:endParaRPr lang="en-US" sz="1900" dirty="0"/>
+          </a:p>
+          <a:p>
+            <a:pPr indent="0" marL="0">
+              <a:buNone/>
+            </a:pPr>
+            <a:r>
+              <a:rPr lang="en-US" sz="1900" dirty="0">
+                <a:solidFill>
+                  <a:srgbClr val="1F2A30"/>
+                </a:solidFill>
+              </a:rPr>
+              <a:t>Dopo ogni conversione: conta i mancanti.</a:t>
+            </a:r>
+            <a:endParaRPr lang="en-US" sz="1900" dirty="0"/>
           </a:p>
         </p:txBody>
       </p:sp>
@@ -5606,7 +5983,7 @@
                   <a:srgbClr val="0F4C5C"/>
                 </a:solidFill>
               </a:rPr>
-              <a:t>Correggere una cella a mano</a:t>
+              <a:t>Correggere solo alcune righe</a:t>
             </a:r>
             <a:endParaRPr lang="en-US" sz="3600" dirty="0"/>
           </a:p>
@@ -5614,126 +5991,18 @@
       </p:sp>
       <p:sp>
         <p:nvSpPr>
-          <p:cNvPr id="3" name="Text 1"/>
-          <p:cNvSpPr txBox="1"/>
-          <p:nvPr/>
-        </p:nvSpPr>
-        <p:spPr>
-          <a:xfrm>
-            <a:off x="548640" y="1600200"/>
-            <a:ext cx="3657600" cy="457200"/>
-          </a:xfrm>
-          <a:prstGeom prst="rect">
-            <a:avLst/>
-          </a:prstGeom>
-          <a:noFill/>
-          <a:ln/>
-        </p:spPr>
-        <p:txBody>
-          <a:bodyPr wrap="square" lIns="0" tIns="0" rIns="0" bIns="0" rtlCol="0" anchor="ctr"/>
-          <a:lstStyle/>
-          <a:p>
-            <a:pPr indent="0" marL="0">
-              <a:buNone/>
-            </a:pPr>
-            <a:r>
-              <a:rPr lang="en-US" sz="2400" b="1" dirty="0">
-                <a:solidFill>
-                  <a:srgbClr val="0F4C5C"/>
-                </a:solidFill>
-              </a:rPr>
-              <a:t>In Excel</a:t>
-            </a:r>
-            <a:endParaRPr lang="en-US" sz="2400" dirty="0"/>
-          </a:p>
-        </p:txBody>
-      </p:sp>
-      <p:sp>
-        <p:nvSpPr>
-          <p:cNvPr id="4" name="Text 2"/>
-          <p:cNvSpPr txBox="1"/>
-          <p:nvPr/>
-        </p:nvSpPr>
-        <p:spPr>
-          <a:xfrm>
-            <a:off x="548640" y="2103120"/>
-            <a:ext cx="3657600" cy="1097280"/>
-          </a:xfrm>
-          <a:prstGeom prst="rect">
-            <a:avLst/>
-          </a:prstGeom>
-          <a:noFill/>
-          <a:ln/>
-        </p:spPr>
-        <p:txBody>
-          <a:bodyPr wrap="square" lIns="0" tIns="0" rIns="0" bIns="0" rtlCol="0" anchor="t"/>
-          <a:lstStyle/>
-          <a:p>
-            <a:pPr indent="0" marL="0">
-              <a:buNone/>
-            </a:pPr>
-            <a:r>
-              <a:rPr lang="en-US" sz="1800" dirty="0">
-                <a:solidFill>
-                  <a:srgbClr val="1F2A30"/>
-                </a:solidFill>
-              </a:rPr>
-              <a:t>clicchi sulla cella, scrivi 12, invio. Nessuno saprà mai che l'hai fatto.</a:t>
-            </a:r>
-            <a:endParaRPr lang="en-US" sz="1800" dirty="0"/>
-          </a:p>
-        </p:txBody>
-      </p:sp>
-      <p:sp>
-        <p:nvSpPr>
-          <p:cNvPr id="5" name="Text 3"/>
-          <p:cNvSpPr txBox="1"/>
-          <p:nvPr/>
-        </p:nvSpPr>
-        <p:spPr>
-          <a:xfrm>
-            <a:off x="4572000" y="1600200"/>
-            <a:ext cx="7040880" cy="457200"/>
-          </a:xfrm>
-          <a:prstGeom prst="rect">
-            <a:avLst/>
-          </a:prstGeom>
-          <a:noFill/>
-          <a:ln/>
-        </p:spPr>
-        <p:txBody>
-          <a:bodyPr wrap="square" lIns="0" tIns="0" rIns="0" bIns="0" rtlCol="0" anchor="ctr"/>
-          <a:lstStyle/>
-          <a:p>
-            <a:pPr indent="0" marL="0">
-              <a:buNone/>
-            </a:pPr>
-            <a:r>
-              <a:rPr lang="en-US" sz="2400" b="1" dirty="0">
-                <a:solidFill>
-                  <a:srgbClr val="0F4C5C"/>
-                </a:solidFill>
-              </a:rPr>
-              <a:t>In Python</a:t>
-            </a:r>
-            <a:endParaRPr lang="en-US" sz="2400" dirty="0"/>
-          </a:p>
-        </p:txBody>
-      </p:sp>
-      <p:sp>
-        <p:nvSpPr>
-          <p:cNvPr id="6" name="card-code"/>
+          <p:cNvPr id="3" name="card-code"/>
           <p:cNvSpPr/>
           <p:nvPr/>
         </p:nvSpPr>
         <p:spPr>
           <a:xfrm>
-            <a:off x="4572000" y="2103120"/>
-            <a:ext cx="7040880" cy="1828800"/>
+            <a:off x="548640" y="1737360"/>
+            <a:ext cx="6583680" cy="1737360"/>
           </a:xfrm>
           <a:prstGeom prst="roundRect">
             <a:avLst>
-              <a:gd name="adj" fmla="val 6000"/>
+              <a:gd name="adj" fmla="val 6316"/>
             </a:avLst>
           </a:prstGeom>
           <a:solidFill>
@@ -5744,13 +6013,13 @@
       </p:sp>
       <p:sp>
         <p:nvSpPr>
-          <p:cNvPr id="7" name="Text 5"/>
+          <p:cNvPr id="4" name="Text 2"/>
           <p:cNvSpPr txBox="1"/>
           <p:nvPr/>
         </p:nvSpPr>
         <p:spPr>
           <a:xfrm>
-            <a:off x="4800600" y="2240280"/>
+            <a:off x="777240" y="1874520"/>
             <a:ext cx="1828800" cy="274320"/>
           </a:xfrm>
           <a:prstGeom prst="rect">
@@ -5780,14 +6049,14 @@
       </p:sp>
       <p:sp>
         <p:nvSpPr>
-          <p:cNvPr id="8" name="Text 6"/>
+          <p:cNvPr id="5" name="Text 3"/>
           <p:cNvSpPr txBox="1"/>
           <p:nvPr/>
         </p:nvSpPr>
         <p:spPr>
           <a:xfrm>
-            <a:off x="4800600" y="2560320"/>
-            <a:ext cx="6583680" cy="1234440"/>
+            <a:off x="777240" y="2194560"/>
+            <a:ext cx="6126480" cy="1143000"/>
           </a:xfrm>
           <a:prstGeom prst="rect">
             <a:avLst/>
@@ -5803,7 +6072,7 @@
               <a:buNone/>
             </a:pPr>
             <a:r>
-              <a:rPr lang="en-US" sz="1600" dirty="0">
+              <a:rPr lang="en-US" sz="1800" dirty="0">
                 <a:solidFill>
                   <a:srgbClr val="FFFFFF"/>
                 </a:solidFill>
@@ -5811,16 +6080,16 @@
                 <a:ea typeface="Courier New" pitchFamily="34" charset="-122"/>
                 <a:cs typeface="Courier New" pitchFamily="34" charset="-120"/>
               </a:rPr>
-              <a:t>riga = ((df["cliente"] == "C042")</a:t>
-            </a:r>
-            <a:endParaRPr lang="en-US" sz="1600" dirty="0"/>
-          </a:p>
-          <a:p>
-            <a:pPr indent="0" marL="0">
-              <a:buNone/>
-            </a:pPr>
-            <a:r>
-              <a:rPr lang="en-US" sz="1600" dirty="0">
+              <a:t>negativi = df["prezzo"] &lt; 0</a:t>
+            </a:r>
+            <a:endParaRPr lang="en-US" sz="1800" dirty="0"/>
+          </a:p>
+          <a:p>
+            <a:pPr indent="0" marL="0">
+              <a:buNone/>
+            </a:pPr>
+            <a:r>
+              <a:rPr lang="en-US" sz="1800" dirty="0">
                 <a:solidFill>
                   <a:srgbClr val="FFFFFF"/>
                 </a:solidFill>
@@ -5828,16 +6097,16 @@
                 <a:ea typeface="Courier New" pitchFamily="34" charset="-122"/>
                 <a:cs typeface="Courier New" pitchFamily="34" charset="-120"/>
               </a:rPr>
-              <a:t>        &amp; (df["anno"] == 2021))</a:t>
-            </a:r>
-            <a:endParaRPr lang="en-US" sz="1600" dirty="0"/>
-          </a:p>
-          <a:p>
-            <a:pPr indent="0" marL="0">
-              <a:buNone/>
-            </a:pPr>
-            <a:r>
-              <a:rPr lang="en-US" sz="1600" dirty="0">
+              <a:t>print(negativi.sum())</a:t>
+            </a:r>
+            <a:endParaRPr lang="en-US" sz="1800" dirty="0"/>
+          </a:p>
+          <a:p>
+            <a:pPr indent="0" marL="0">
+              <a:buNone/>
+            </a:pPr>
+            <a:r>
+              <a:rPr lang="en-US" sz="1800" dirty="0">
                 <a:solidFill>
                   <a:srgbClr val="FFFFFF"/>
                 </a:solidFill>
@@ -5845,16 +6114,192 @@
                 <a:ea typeface="Courier New" pitchFamily="34" charset="-122"/>
                 <a:cs typeface="Courier New" pitchFamily="34" charset="-120"/>
               </a:rPr>
-              <a:t>print(riga.sum())     # deve dare 1</a:t>
-            </a:r>
-            <a:endParaRPr lang="en-US" sz="1600" dirty="0"/>
-          </a:p>
-          <a:p>
-            <a:pPr indent="0" marL="0">
-              <a:buNone/>
-            </a:pPr>
-            <a:r>
-              <a:rPr lang="en-US" sz="1600" dirty="0">
+              <a:t>df.loc[negativi, "prezzo"] = None</a:t>
+            </a:r>
+            <a:endParaRPr lang="en-US" sz="1800" dirty="0"/>
+          </a:p>
+        </p:txBody>
+      </p:sp>
+      <p:sp>
+        <p:nvSpPr>
+          <p:cNvPr id="6" name="Text 4"/>
+          <p:cNvSpPr txBox="1"/>
+          <p:nvPr/>
+        </p:nvSpPr>
+        <p:spPr>
+          <a:xfrm>
+            <a:off x="548640" y="3749040"/>
+            <a:ext cx="6583680" cy="1828800"/>
+          </a:xfrm>
+          <a:prstGeom prst="rect">
+            <a:avLst/>
+          </a:prstGeom>
+          <a:noFill/>
+          <a:ln/>
+        </p:spPr>
+        <p:txBody>
+          <a:bodyPr wrap="square" lIns="0" tIns="0" rIns="0" bIns="0" rtlCol="0" anchor="t"/>
+          <a:lstStyle/>
+          <a:p>
+            <a:pPr marL="342900" indent="-342900">
+              <a:spcAft>
+                <a:spcPts val="1000"/>
+              </a:spcAft>
+              <a:buSzPct val="100000"/>
+              <a:buChar char="•"/>
+            </a:pPr>
+            <a:r>
+              <a:rPr lang="en-US" sz="1800" dirty="0">
+                <a:solidFill>
+                  <a:srgbClr val="1F2A30"/>
+                </a:solidFill>
+              </a:rPr>
+              <a:t>Una condizione è una colonna di True e False</a:t>
+            </a:r>
+            <a:endParaRPr lang="en-US" sz="1800" dirty="0"/>
+          </a:p>
+          <a:p>
+            <a:pPr marL="342900" indent="-342900">
+              <a:spcAft>
+                <a:spcPts val="1000"/>
+              </a:spcAft>
+              <a:buSzPct val="100000"/>
+              <a:buChar char="•"/>
+            </a:pPr>
+            <a:r>
+              <a:rPr lang="en-US" sz="1800" dirty="0">
+                <a:solidFill>
+                  <a:srgbClr val="1F2A30"/>
+                </a:solidFill>
+              </a:rPr>
+              <a:t>.sum() conta quante righe la rispettano</a:t>
+            </a:r>
+            <a:endParaRPr lang="en-US" sz="1800" dirty="0"/>
+          </a:p>
+          <a:p>
+            <a:pPr marL="342900" indent="-342900">
+              <a:spcAft>
+                <a:spcPts val="1000"/>
+              </a:spcAft>
+              <a:buSzPct val="100000"/>
+              <a:buChar char="•"/>
+            </a:pPr>
+            <a:r>
+              <a:rPr lang="en-US" sz="1800" dirty="0">
+                <a:solidFill>
+                  <a:srgbClr val="1F2A30"/>
+                </a:solidFill>
+              </a:rPr>
+              <a:t>.loc[righe, colonna] = valore</a:t>
+            </a:r>
+            <a:endParaRPr lang="en-US" sz="1800" dirty="0"/>
+          </a:p>
+        </p:txBody>
+      </p:sp>
+      <p:sp>
+        <p:nvSpPr>
+          <p:cNvPr id="7" name="Shape 5"/>
+          <p:cNvSpPr/>
+          <p:nvPr/>
+        </p:nvSpPr>
+        <p:spPr>
+          <a:xfrm>
+            <a:off x="7589520" y="1737360"/>
+            <a:ext cx="4023360" cy="3840480"/>
+          </a:xfrm>
+          <a:prstGeom prst="roundRect">
+            <a:avLst>
+              <a:gd name="adj" fmla="val 2857"/>
+            </a:avLst>
+          </a:prstGeom>
+          <a:solidFill>
+            <a:srgbClr val="0F4C5C"/>
+          </a:solidFill>
+          <a:ln/>
+        </p:spPr>
+      </p:sp>
+      <p:sp>
+        <p:nvSpPr>
+          <p:cNvPr id="8" name="Text 6"/>
+          <p:cNvSpPr txBox="1"/>
+          <p:nvPr/>
+        </p:nvSpPr>
+        <p:spPr>
+          <a:xfrm>
+            <a:off x="7863840" y="1965960"/>
+            <a:ext cx="3474720" cy="365760"/>
+          </a:xfrm>
+          <a:prstGeom prst="rect">
+            <a:avLst/>
+          </a:prstGeom>
+          <a:noFill/>
+          <a:ln/>
+        </p:spPr>
+        <p:txBody>
+          <a:bodyPr wrap="square" lIns="0" tIns="0" rIns="0" bIns="0" rtlCol="0" anchor="ctr"/>
+          <a:lstStyle/>
+          <a:p>
+            <a:pPr indent="0" marL="0">
+              <a:buNone/>
+            </a:pPr>
+            <a:r>
+              <a:rPr lang="en-US" sz="1300" b="1" spc="200" kern="0" dirty="0">
+                <a:solidFill>
+                  <a:srgbClr val="F4C06E"/>
+                </a:solidFill>
+              </a:rPr>
+              <a:t>MANCANTE NON È ZERO</a:t>
+            </a:r>
+            <a:endParaRPr lang="en-US" sz="1300" dirty="0"/>
+          </a:p>
+        </p:txBody>
+      </p:sp>
+      <p:sp>
+        <p:nvSpPr>
+          <p:cNvPr id="9" name="Text 7"/>
+          <p:cNvSpPr txBox="1"/>
+          <p:nvPr/>
+        </p:nvSpPr>
+        <p:spPr>
+          <a:xfrm>
+            <a:off x="7863840" y="2468880"/>
+            <a:ext cx="3474720" cy="2926080"/>
+          </a:xfrm>
+          <a:prstGeom prst="rect">
+            <a:avLst/>
+          </a:prstGeom>
+          <a:noFill/>
+          <a:ln/>
+        </p:spPr>
+        <p:txBody>
+          <a:bodyPr wrap="square" lIns="0" tIns="0" rIns="0" bIns="0" rtlCol="0" anchor="t"/>
+          <a:lstStyle/>
+          <a:p>
+            <a:pPr indent="0" marL="0">
+              <a:spcAft>
+                <a:spcPts val="1200"/>
+              </a:spcAft>
+              <a:buNone/>
+            </a:pPr>
+            <a:r>
+              <a:rPr lang="en-US" sz="2000" dirty="0">
+                <a:solidFill>
+                  <a:srgbClr val="FFFFFF"/>
+                </a:solidFill>
+              </a:rPr>
+              <a:t>Media di 10, ?, 20</a:t>
+            </a:r>
+            <a:endParaRPr lang="en-US" sz="2000" dirty="0"/>
+          </a:p>
+          <a:p>
+            <a:pPr indent="0" marL="0">
+              <a:spcAft>
+                <a:spcPts val="1200"/>
+              </a:spcAft>
+              <a:buNone/>
+            </a:pPr>
+            <a:r>
+              <a:rPr lang="en-US" sz="2000" dirty="0">
                 <a:solidFill>
                   <a:srgbClr val="FFFFFF"/>
                 </a:solidFill>
@@ -5862,345 +6307,29 @@
                 <a:ea typeface="Courier New" pitchFamily="34" charset="-122"/>
                 <a:cs typeface="Courier New" pitchFamily="34" charset="-120"/>
               </a:rPr>
-              <a:t>df.loc[riga, "ordini"] = 12</a:t>
-            </a:r>
-            <a:endParaRPr lang="en-US" sz="1600" dirty="0"/>
-          </a:p>
-        </p:txBody>
-      </p:sp>
-      <p:sp>
-        <p:nvSpPr>
-          <p:cNvPr id="9" name="Shape 7"/>
-          <p:cNvSpPr/>
-          <p:nvPr/>
-        </p:nvSpPr>
-        <p:spPr>
-          <a:xfrm>
-            <a:off x="548640" y="4251960"/>
-            <a:ext cx="5440680" cy="1325880"/>
-          </a:xfrm>
-          <a:prstGeom prst="roundRect">
-            <a:avLst>
-              <a:gd name="adj" fmla="val 8276"/>
-            </a:avLst>
-          </a:prstGeom>
-          <a:solidFill>
-            <a:srgbClr val="EEF3F4"/>
-          </a:solidFill>
-          <a:ln/>
-        </p:spPr>
-      </p:sp>
-      <p:sp>
-        <p:nvSpPr>
-          <p:cNvPr id="10" name="Shape 8"/>
-          <p:cNvSpPr/>
-          <p:nvPr/>
-        </p:nvSpPr>
-        <p:spPr>
-          <a:xfrm>
-            <a:off x="822960" y="4553712"/>
-            <a:ext cx="685800" cy="685800"/>
-          </a:xfrm>
-          <a:prstGeom prst="ellipse">
-            <a:avLst/>
-          </a:prstGeom>
-          <a:solidFill>
-            <a:srgbClr val="E09F3E"/>
-          </a:solidFill>
-          <a:ln/>
-        </p:spPr>
-      </p:sp>
-      <p:sp>
-        <p:nvSpPr>
-          <p:cNvPr id="11" name="Text 9"/>
-          <p:cNvSpPr txBox="1"/>
-          <p:nvPr/>
-        </p:nvSpPr>
-        <p:spPr>
-          <a:xfrm>
-            <a:off x="822960" y="4553712"/>
-            <a:ext cx="685800" cy="685800"/>
-          </a:xfrm>
-          <a:prstGeom prst="rect">
-            <a:avLst/>
-          </a:prstGeom>
-          <a:noFill/>
-          <a:ln/>
-        </p:spPr>
-        <p:txBody>
-          <a:bodyPr wrap="square" lIns="0" tIns="0" rIns="0" bIns="0" rtlCol="0" anchor="ctr"/>
-          <a:lstStyle/>
-          <a:p>
-            <a:pPr algn="ctr" indent="0" marL="0">
-              <a:buNone/>
-            </a:pPr>
-            <a:r>
-              <a:rPr lang="en-US" sz="1950" b="1" dirty="0">
-                <a:solidFill>
-                  <a:srgbClr val="1F2A30"/>
-                </a:solidFill>
-              </a:rPr>
-              <a:t>1</a:t>
-            </a:r>
-            <a:endParaRPr lang="en-US" sz="1950" dirty="0"/>
-          </a:p>
-        </p:txBody>
-      </p:sp>
-      <p:sp>
-        <p:nvSpPr>
-          <p:cNvPr id="12" name="Text 10"/>
-          <p:cNvSpPr txBox="1"/>
-          <p:nvPr/>
-        </p:nvSpPr>
-        <p:spPr>
-          <a:xfrm>
-            <a:off x="1737360" y="4434840"/>
-            <a:ext cx="4069080" cy="457200"/>
-          </a:xfrm>
-          <a:prstGeom prst="rect">
-            <a:avLst/>
-          </a:prstGeom>
-          <a:noFill/>
-          <a:ln/>
-        </p:spPr>
-        <p:txBody>
-          <a:bodyPr wrap="square" lIns="0" tIns="0" rIns="0" bIns="0" rtlCol="0" anchor="ctr"/>
-          <a:lstStyle/>
-          <a:p>
-            <a:pPr indent="0" marL="0">
-              <a:buNone/>
-            </a:pPr>
-            <a:r>
-              <a:rPr lang="en-US" sz="2000" b="1" dirty="0">
-                <a:solidFill>
-                  <a:srgbClr val="1F2A30"/>
-                </a:solidFill>
-              </a:rPr>
-              <a:t>Sempre nel codice</a:t>
+              <a:t>con il mancante: 15</a:t>
             </a:r>
             <a:endParaRPr lang="en-US" sz="2000" dirty="0"/>
           </a:p>
-        </p:txBody>
-      </p:sp>
-      <p:sp>
-        <p:nvSpPr>
-          <p:cNvPr id="13" name="Text 11"/>
-          <p:cNvSpPr txBox="1"/>
-          <p:nvPr/>
-        </p:nvSpPr>
-        <p:spPr>
-          <a:xfrm>
-            <a:off x="1737360" y="4892040"/>
-            <a:ext cx="4069080" cy="502920"/>
-          </a:xfrm>
-          <a:prstGeom prst="rect">
-            <a:avLst/>
-          </a:prstGeom>
-          <a:noFill/>
-          <a:ln/>
-        </p:spPr>
-        <p:txBody>
-          <a:bodyPr wrap="square" lIns="0" tIns="0" rIns="0" bIns="0" rtlCol="0" anchor="ctr"/>
-          <a:lstStyle/>
-          <a:p>
-            <a:pPr indent="0" marL="0">
-              <a:buNone/>
-            </a:pPr>
-            <a:r>
-              <a:rPr lang="en-US" sz="1600" dirty="0">
-                <a:solidFill>
-                  <a:srgbClr val="5C6F7B"/>
-                </a:solidFill>
-              </a:rPr>
-              <a:t>la correzione resta scritta e si può rifare</a:t>
-            </a:r>
-            <a:endParaRPr lang="en-US" sz="1600" dirty="0"/>
-          </a:p>
-        </p:txBody>
-      </p:sp>
-      <p:sp>
-        <p:nvSpPr>
-          <p:cNvPr id="14" name="Shape 12"/>
-          <p:cNvSpPr/>
-          <p:nvPr/>
-        </p:nvSpPr>
-        <p:spPr>
-          <a:xfrm>
-            <a:off x="6172200" y="4251960"/>
-            <a:ext cx="5440680" cy="1325880"/>
-          </a:xfrm>
-          <a:prstGeom prst="roundRect">
-            <a:avLst>
-              <a:gd name="adj" fmla="val 8276"/>
-            </a:avLst>
-          </a:prstGeom>
-          <a:solidFill>
-            <a:srgbClr val="EEF3F4"/>
-          </a:solidFill>
-          <a:ln/>
-        </p:spPr>
-      </p:sp>
-      <p:sp>
-        <p:nvSpPr>
-          <p:cNvPr id="15" name="Shape 13"/>
-          <p:cNvSpPr/>
-          <p:nvPr/>
-        </p:nvSpPr>
-        <p:spPr>
-          <a:xfrm>
-            <a:off x="6446520" y="4553712"/>
-            <a:ext cx="685800" cy="685800"/>
-          </a:xfrm>
-          <a:prstGeom prst="ellipse">
-            <a:avLst/>
-          </a:prstGeom>
-          <a:solidFill>
-            <a:srgbClr val="E09F3E"/>
-          </a:solidFill>
-          <a:ln/>
-        </p:spPr>
-      </p:sp>
-      <p:sp>
-        <p:nvSpPr>
-          <p:cNvPr id="16" name="Text 14"/>
-          <p:cNvSpPr txBox="1"/>
-          <p:nvPr/>
-        </p:nvSpPr>
-        <p:spPr>
-          <a:xfrm>
-            <a:off x="6446520" y="4553712"/>
-            <a:ext cx="685800" cy="685800"/>
-          </a:xfrm>
-          <a:prstGeom prst="rect">
-            <a:avLst/>
-          </a:prstGeom>
-          <a:noFill/>
-          <a:ln/>
-        </p:spPr>
-        <p:txBody>
-          <a:bodyPr wrap="square" lIns="0" tIns="0" rIns="0" bIns="0" rtlCol="0" anchor="ctr"/>
-          <a:lstStyle/>
-          <a:p>
-            <a:pPr algn="ctr" indent="0" marL="0">
-              <a:buNone/>
-            </a:pPr>
-            <a:r>
-              <a:rPr lang="en-US" sz="1950" b="1" dirty="0">
-                <a:solidFill>
-                  <a:srgbClr val="1F2A30"/>
-                </a:solidFill>
-              </a:rPr>
-              <a:t>2</a:t>
-            </a:r>
-            <a:endParaRPr lang="en-US" sz="1950" dirty="0"/>
-          </a:p>
-        </p:txBody>
-      </p:sp>
-      <p:sp>
-        <p:nvSpPr>
-          <p:cNvPr id="17" name="Text 15"/>
-          <p:cNvSpPr txBox="1"/>
-          <p:nvPr/>
-        </p:nvSpPr>
-        <p:spPr>
-          <a:xfrm>
-            <a:off x="7360920" y="4434840"/>
-            <a:ext cx="4069080" cy="457200"/>
-          </a:xfrm>
-          <a:prstGeom prst="rect">
-            <a:avLst/>
-          </a:prstGeom>
-          <a:noFill/>
-          <a:ln/>
-        </p:spPr>
-        <p:txBody>
-          <a:bodyPr wrap="square" lIns="0" tIns="0" rIns="0" bIns="0" rtlCol="0" anchor="ctr"/>
-          <a:lstStyle/>
-          <a:p>
-            <a:pPr indent="0" marL="0">
-              <a:buNone/>
-            </a:pPr>
-            <a:r>
-              <a:rPr lang="en-US" sz="2000" b="1" dirty="0">
-                <a:solidFill>
-                  <a:srgbClr val="1F2A30"/>
-                </a:solidFill>
-              </a:rPr>
-              <a:t>Per contenuto, non per numero di riga</a:t>
+          <a:p>
+            <a:pPr indent="0" marL="0">
+              <a:spcAft>
+                <a:spcPts val="1200"/>
+              </a:spcAft>
+              <a:buNone/>
+            </a:pPr>
+            <a:r>
+              <a:rPr lang="en-US" sz="2000" dirty="0">
+                <a:solidFill>
+                  <a:srgbClr val="FFFFFF"/>
+                </a:solidFill>
+                <a:latin typeface="Courier New" pitchFamily="34" charset="0"/>
+                <a:ea typeface="Courier New" pitchFamily="34" charset="-122"/>
+                <a:cs typeface="Courier New" pitchFamily="34" charset="-120"/>
+              </a:rPr>
+              <a:t>con lo 0:       10</a:t>
             </a:r>
             <a:endParaRPr lang="en-US" sz="2000" dirty="0"/>
-          </a:p>
-        </p:txBody>
-      </p:sp>
-      <p:sp>
-        <p:nvSpPr>
-          <p:cNvPr id="18" name="Text 16"/>
-          <p:cNvSpPr txBox="1"/>
-          <p:nvPr/>
-        </p:nvSpPr>
-        <p:spPr>
-          <a:xfrm>
-            <a:off x="7360920" y="4892040"/>
-            <a:ext cx="4069080" cy="502920"/>
-          </a:xfrm>
-          <a:prstGeom prst="rect">
-            <a:avLst/>
-          </a:prstGeom>
-          <a:noFill/>
-          <a:ln/>
-        </p:spPr>
-        <p:txBody>
-          <a:bodyPr wrap="square" lIns="0" tIns="0" rIns="0" bIns="0" rtlCol="0" anchor="ctr"/>
-          <a:lstStyle/>
-          <a:p>
-            <a:pPr indent="0" marL="0">
-              <a:buNone/>
-            </a:pPr>
-            <a:r>
-              <a:rPr lang="en-US" sz="1600" dirty="0">
-                <a:solidFill>
-                  <a:srgbClr val="5C6F7B"/>
-                </a:solidFill>
-              </a:rPr>
-              <a:t>dopo un ordinamento la riga 500 è un'altra</a:t>
-            </a:r>
-            <a:endParaRPr lang="en-US" sz="1600" dirty="0"/>
-          </a:p>
-        </p:txBody>
-      </p:sp>
-      <p:sp>
-        <p:nvSpPr>
-          <p:cNvPr id="19" name="Text 17"/>
-          <p:cNvSpPr txBox="1"/>
-          <p:nvPr/>
-        </p:nvSpPr>
-        <p:spPr>
-          <a:xfrm>
-            <a:off x="548640" y="5760720"/>
-            <a:ext cx="11064240" cy="411480"/>
-          </a:xfrm>
-          <a:prstGeom prst="rect">
-            <a:avLst/>
-          </a:prstGeom>
-          <a:noFill/>
-          <a:ln/>
-        </p:spPr>
-        <p:txBody>
-          <a:bodyPr wrap="square" lIns="0" tIns="0" rIns="0" bIns="0" rtlCol="0" anchor="ctr"/>
-          <a:lstStyle/>
-          <a:p>
-            <a:pPr indent="0" marL="0">
-              <a:buNone/>
-            </a:pPr>
-            <a:r>
-              <a:rPr lang="en-US" sz="1700" i="1" dirty="0">
-                <a:solidFill>
-                  <a:srgbClr val="0F4C5C"/>
-                </a:solidFill>
-              </a:rPr>
-              <a:t>Due condizioni insieme: &amp;, e ognuna tra parentesi.</a:t>
-            </a:r>
-            <a:endParaRPr lang="en-US" sz="1700" dirty="0"/>
           </a:p>
         </p:txBody>
       </p:sp>
@@ -6284,83 +6413,668 @@
         </p:nvSpPr>
         <p:spPr>
           <a:xfrm>
-            <a:off x="731520" y="2194560"/>
-            <a:ext cx="10698480" cy="1280160"/>
-          </a:xfrm>
-          <a:prstGeom prst="rect">
-            <a:avLst/>
-          </a:prstGeom>
-          <a:noFill/>
-          <a:ln/>
-        </p:spPr>
-        <p:txBody>
-          <a:bodyPr wrap="square" lIns="0" tIns="0" rIns="0" bIns="0" rtlCol="0" anchor="b"/>
+            <a:off x="548640" y="365760"/>
+            <a:ext cx="11064240" cy="822960"/>
+          </a:xfrm>
+          <a:prstGeom prst="rect">
+            <a:avLst/>
+          </a:prstGeom>
+          <a:noFill/>
+          <a:ln/>
+        </p:spPr>
+        <p:txBody>
+          <a:bodyPr wrap="square" lIns="0" tIns="0" rIns="0" bIns="0" rtlCol="0" anchor="ctr"/>
           <a:lstStyle/>
           <a:p>
             <a:pPr algn="l" indent="0" marL="0">
               <a:buNone/>
             </a:pPr>
             <a:r>
-              <a:rPr lang="en-US" sz="5400" b="1" dirty="0">
+              <a:rPr lang="en-US" sz="3600" b="1" dirty="0">
+                <a:solidFill>
+                  <a:srgbClr val="0F4C5C"/>
+                </a:solidFill>
+              </a:rPr>
+              <a:t>Correggere una cella a mano</a:t>
+            </a:r>
+            <a:endParaRPr lang="en-US" sz="3600" dirty="0"/>
+          </a:p>
+        </p:txBody>
+      </p:sp>
+      <p:sp>
+        <p:nvSpPr>
+          <p:cNvPr id="3" name="Text 1"/>
+          <p:cNvSpPr txBox="1"/>
+          <p:nvPr/>
+        </p:nvSpPr>
+        <p:spPr>
+          <a:xfrm>
+            <a:off x="548640" y="1600200"/>
+            <a:ext cx="3657600" cy="457200"/>
+          </a:xfrm>
+          <a:prstGeom prst="rect">
+            <a:avLst/>
+          </a:prstGeom>
+          <a:noFill/>
+          <a:ln/>
+        </p:spPr>
+        <p:txBody>
+          <a:bodyPr wrap="square" lIns="0" tIns="0" rIns="0" bIns="0" rtlCol="0" anchor="ctr"/>
+          <a:lstStyle/>
+          <a:p>
+            <a:pPr indent="0" marL="0">
+              <a:buNone/>
+            </a:pPr>
+            <a:r>
+              <a:rPr lang="en-US" sz="2400" b="1" dirty="0">
+                <a:solidFill>
+                  <a:srgbClr val="0F4C5C"/>
+                </a:solidFill>
+              </a:rPr>
+              <a:t>In Excel</a:t>
+            </a:r>
+            <a:endParaRPr lang="en-US" sz="2400" dirty="0"/>
+          </a:p>
+        </p:txBody>
+      </p:sp>
+      <p:sp>
+        <p:nvSpPr>
+          <p:cNvPr id="4" name="Text 2"/>
+          <p:cNvSpPr txBox="1"/>
+          <p:nvPr/>
+        </p:nvSpPr>
+        <p:spPr>
+          <a:xfrm>
+            <a:off x="548640" y="2103120"/>
+            <a:ext cx="3657600" cy="1097280"/>
+          </a:xfrm>
+          <a:prstGeom prst="rect">
+            <a:avLst/>
+          </a:prstGeom>
+          <a:noFill/>
+          <a:ln/>
+        </p:spPr>
+        <p:txBody>
+          <a:bodyPr wrap="square" lIns="0" tIns="0" rIns="0" bIns="0" rtlCol="0" anchor="t"/>
+          <a:lstStyle/>
+          <a:p>
+            <a:pPr indent="0" marL="0">
+              <a:buNone/>
+            </a:pPr>
+            <a:r>
+              <a:rPr lang="en-US" sz="1800" dirty="0">
+                <a:solidFill>
+                  <a:srgbClr val="1F2A30"/>
+                </a:solidFill>
+              </a:rPr>
+              <a:t>clicchi sulla cella, scrivi 12, invio. Nessuno saprà mai che l'hai fatto.</a:t>
+            </a:r>
+            <a:endParaRPr lang="en-US" sz="1800" dirty="0"/>
+          </a:p>
+        </p:txBody>
+      </p:sp>
+      <p:sp>
+        <p:nvSpPr>
+          <p:cNvPr id="5" name="Text 3"/>
+          <p:cNvSpPr txBox="1"/>
+          <p:nvPr/>
+        </p:nvSpPr>
+        <p:spPr>
+          <a:xfrm>
+            <a:off x="4572000" y="1600200"/>
+            <a:ext cx="7040880" cy="457200"/>
+          </a:xfrm>
+          <a:prstGeom prst="rect">
+            <a:avLst/>
+          </a:prstGeom>
+          <a:noFill/>
+          <a:ln/>
+        </p:spPr>
+        <p:txBody>
+          <a:bodyPr wrap="square" lIns="0" tIns="0" rIns="0" bIns="0" rtlCol="0" anchor="ctr"/>
+          <a:lstStyle/>
+          <a:p>
+            <a:pPr indent="0" marL="0">
+              <a:buNone/>
+            </a:pPr>
+            <a:r>
+              <a:rPr lang="en-US" sz="2400" b="1" dirty="0">
+                <a:solidFill>
+                  <a:srgbClr val="0F4C5C"/>
+                </a:solidFill>
+              </a:rPr>
+              <a:t>In Python</a:t>
+            </a:r>
+            <a:endParaRPr lang="en-US" sz="2400" dirty="0"/>
+          </a:p>
+        </p:txBody>
+      </p:sp>
+      <p:sp>
+        <p:nvSpPr>
+          <p:cNvPr id="6" name="card-code"/>
+          <p:cNvSpPr/>
+          <p:nvPr/>
+        </p:nvSpPr>
+        <p:spPr>
+          <a:xfrm>
+            <a:off x="4572000" y="2103120"/>
+            <a:ext cx="7040880" cy="1828800"/>
+          </a:xfrm>
+          <a:prstGeom prst="roundRect">
+            <a:avLst>
+              <a:gd name="adj" fmla="val 6000"/>
+            </a:avLst>
+          </a:prstGeom>
+          <a:solidFill>
+            <a:srgbClr val="1F2A30"/>
+          </a:solidFill>
+          <a:ln/>
+        </p:spPr>
+      </p:sp>
+      <p:sp>
+        <p:nvSpPr>
+          <p:cNvPr id="7" name="Text 5"/>
+          <p:cNvSpPr txBox="1"/>
+          <p:nvPr/>
+        </p:nvSpPr>
+        <p:spPr>
+          <a:xfrm>
+            <a:off x="4800600" y="2240280"/>
+            <a:ext cx="1828800" cy="274320"/>
+          </a:xfrm>
+          <a:prstGeom prst="rect">
+            <a:avLst/>
+          </a:prstGeom>
+          <a:noFill/>
+          <a:ln/>
+        </p:spPr>
+        <p:txBody>
+          <a:bodyPr wrap="square" lIns="0" tIns="0" rIns="0" bIns="0" rtlCol="0" anchor="ctr"/>
+          <a:lstStyle/>
+          <a:p>
+            <a:pPr indent="0" marL="0">
+              <a:buNone/>
+            </a:pPr>
+            <a:r>
+              <a:rPr lang="en-US" sz="1100" b="1" spc="200" kern="0" dirty="0">
+                <a:solidFill>
+                  <a:srgbClr val="E09F3E"/>
+                </a:solidFill>
+              </a:rPr>
+              <a:t>PYTHON</a:t>
+            </a:r>
+            <a:endParaRPr lang="en-US" sz="1100" dirty="0"/>
+          </a:p>
+        </p:txBody>
+      </p:sp>
+      <p:sp>
+        <p:nvSpPr>
+          <p:cNvPr id="8" name="Text 6"/>
+          <p:cNvSpPr txBox="1"/>
+          <p:nvPr/>
+        </p:nvSpPr>
+        <p:spPr>
+          <a:xfrm>
+            <a:off x="4800600" y="2560320"/>
+            <a:ext cx="6583680" cy="1234440"/>
+          </a:xfrm>
+          <a:prstGeom prst="rect">
+            <a:avLst/>
+          </a:prstGeom>
+          <a:noFill/>
+          <a:ln/>
+        </p:spPr>
+        <p:txBody>
+          <a:bodyPr wrap="square" lIns="0" tIns="0" rIns="0" bIns="0" rtlCol="0" anchor="t"/>
+          <a:lstStyle/>
+          <a:p>
+            <a:pPr indent="0" marL="0">
+              <a:buNone/>
+            </a:pPr>
+            <a:r>
+              <a:rPr lang="en-US" sz="1600" dirty="0">
                 <a:solidFill>
                   <a:srgbClr val="FFFFFF"/>
                 </a:solidFill>
-              </a:rPr>
-              <a:t>Task: pulisci il dataset</a:t>
-            </a:r>
-            <a:endParaRPr lang="en-US" sz="5400" dirty="0"/>
-          </a:p>
-        </p:txBody>
-      </p:sp>
-      <p:sp>
-        <p:nvSpPr>
-          <p:cNvPr id="3" name="Text 0"/>
+                <a:latin typeface="Courier New" pitchFamily="34" charset="0"/>
+                <a:ea typeface="Courier New" pitchFamily="34" charset="-122"/>
+                <a:cs typeface="Courier New" pitchFamily="34" charset="-120"/>
+              </a:rPr>
+              <a:t>riga = ((df["cliente"] == "C042")</a:t>
+            </a:r>
+            <a:endParaRPr lang="en-US" sz="1600" dirty="0"/>
+          </a:p>
+          <a:p>
+            <a:pPr indent="0" marL="0">
+              <a:buNone/>
+            </a:pPr>
+            <a:r>
+              <a:rPr lang="en-US" sz="1600" dirty="0">
+                <a:solidFill>
+                  <a:srgbClr val="FFFFFF"/>
+                </a:solidFill>
+                <a:latin typeface="Courier New" pitchFamily="34" charset="0"/>
+                <a:ea typeface="Courier New" pitchFamily="34" charset="-122"/>
+                <a:cs typeface="Courier New" pitchFamily="34" charset="-120"/>
+              </a:rPr>
+              <a:t>        &amp; (df["anno"] == 2021))</a:t>
+            </a:r>
+            <a:endParaRPr lang="en-US" sz="1600" dirty="0"/>
+          </a:p>
+          <a:p>
+            <a:pPr indent="0" marL="0">
+              <a:buNone/>
+            </a:pPr>
+            <a:r>
+              <a:rPr lang="en-US" sz="1600" dirty="0">
+                <a:solidFill>
+                  <a:srgbClr val="FFFFFF"/>
+                </a:solidFill>
+                <a:latin typeface="Courier New" pitchFamily="34" charset="0"/>
+                <a:ea typeface="Courier New" pitchFamily="34" charset="-122"/>
+                <a:cs typeface="Courier New" pitchFamily="34" charset="-120"/>
+              </a:rPr>
+              <a:t>print(riga.sum())     # deve dare 1</a:t>
+            </a:r>
+            <a:endParaRPr lang="en-US" sz="1600" dirty="0"/>
+          </a:p>
+          <a:p>
+            <a:pPr indent="0" marL="0">
+              <a:buNone/>
+            </a:pPr>
+            <a:r>
+              <a:rPr lang="en-US" sz="1600" dirty="0">
+                <a:solidFill>
+                  <a:srgbClr val="FFFFFF"/>
+                </a:solidFill>
+                <a:latin typeface="Courier New" pitchFamily="34" charset="0"/>
+                <a:ea typeface="Courier New" pitchFamily="34" charset="-122"/>
+                <a:cs typeface="Courier New" pitchFamily="34" charset="-120"/>
+              </a:rPr>
+              <a:t>df.loc[riga, "ordini"] = 12</a:t>
+            </a:r>
+            <a:endParaRPr lang="en-US" sz="1600" dirty="0"/>
+          </a:p>
+        </p:txBody>
+      </p:sp>
+      <p:sp>
+        <p:nvSpPr>
+          <p:cNvPr id="9" name="Shape 7"/>
           <p:cNvSpPr/>
+          <p:nvPr/>
+        </p:nvSpPr>
+        <p:spPr>
+          <a:xfrm>
+            <a:off x="548640" y="4251960"/>
+            <a:ext cx="5440680" cy="1325880"/>
+          </a:xfrm>
+          <a:prstGeom prst="roundRect">
+            <a:avLst>
+              <a:gd name="adj" fmla="val 8276"/>
+            </a:avLst>
+          </a:prstGeom>
+          <a:solidFill>
+            <a:srgbClr val="EEF3F4"/>
+          </a:solidFill>
+          <a:ln/>
+        </p:spPr>
+      </p:sp>
+      <p:sp>
+        <p:nvSpPr>
+          <p:cNvPr id="10" name="Shape 8"/>
+          <p:cNvSpPr/>
+          <p:nvPr/>
+        </p:nvSpPr>
+        <p:spPr>
+          <a:xfrm>
+            <a:off x="822960" y="4553712"/>
+            <a:ext cx="685800" cy="685800"/>
+          </a:xfrm>
+          <a:prstGeom prst="ellipse">
+            <a:avLst/>
+          </a:prstGeom>
+          <a:solidFill>
+            <a:srgbClr val="E09F3E"/>
+          </a:solidFill>
+          <a:ln/>
+        </p:spPr>
+      </p:sp>
+      <p:sp>
+        <p:nvSpPr>
+          <p:cNvPr id="11" name="Text 9"/>
+          <p:cNvSpPr txBox="1"/>
+          <p:nvPr/>
+        </p:nvSpPr>
+        <p:spPr>
+          <a:xfrm>
+            <a:off x="822960" y="4553712"/>
+            <a:ext cx="685800" cy="685800"/>
+          </a:xfrm>
+          <a:prstGeom prst="rect">
+            <a:avLst/>
+          </a:prstGeom>
+          <a:noFill/>
+          <a:ln/>
+        </p:spPr>
+        <p:txBody>
+          <a:bodyPr wrap="square" lIns="0" tIns="0" rIns="0" bIns="0" rtlCol="0" anchor="ctr"/>
+          <a:lstStyle/>
+          <a:p>
+            <a:pPr algn="ctr" indent="0" marL="0">
+              <a:buNone/>
+            </a:pPr>
+            <a:r>
+              <a:rPr lang="en-US" sz="1950" b="1" dirty="0">
+                <a:solidFill>
+                  <a:srgbClr val="1F2A30"/>
+                </a:solidFill>
+              </a:rPr>
+              <a:t>1</a:t>
+            </a:r>
+            <a:endParaRPr lang="en-US" sz="1950" dirty="0"/>
+          </a:p>
+        </p:txBody>
+      </p:sp>
+      <p:sp>
+        <p:nvSpPr>
+          <p:cNvPr id="12" name="Text 10"/>
+          <p:cNvSpPr txBox="1"/>
+          <p:nvPr/>
+        </p:nvSpPr>
+        <p:spPr>
+          <a:xfrm>
+            <a:off x="1737360" y="4434840"/>
+            <a:ext cx="4069080" cy="457200"/>
+          </a:xfrm>
+          <a:prstGeom prst="rect">
+            <a:avLst/>
+          </a:prstGeom>
+          <a:noFill/>
+          <a:ln/>
+        </p:spPr>
+        <p:txBody>
+          <a:bodyPr wrap="square" lIns="0" tIns="0" rIns="0" bIns="0" rtlCol="0" anchor="ctr"/>
+          <a:lstStyle/>
+          <a:p>
+            <a:pPr indent="0" marL="0">
+              <a:buNone/>
+            </a:pPr>
+            <a:r>
+              <a:rPr lang="en-US" sz="2000" b="1" dirty="0">
+                <a:solidFill>
+                  <a:srgbClr val="1F2A30"/>
+                </a:solidFill>
+              </a:rPr>
+              <a:t>Sempre nel codice</a:t>
+            </a:r>
+            <a:endParaRPr lang="en-US" sz="2000" dirty="0"/>
+          </a:p>
+        </p:txBody>
+      </p:sp>
+      <p:sp>
+        <p:nvSpPr>
+          <p:cNvPr id="13" name="Text 11"/>
+          <p:cNvSpPr txBox="1"/>
+          <p:nvPr/>
+        </p:nvSpPr>
+        <p:spPr>
+          <a:xfrm>
+            <a:off x="1737360" y="4892040"/>
+            <a:ext cx="4069080" cy="502920"/>
+          </a:xfrm>
+          <a:prstGeom prst="rect">
+            <a:avLst/>
+          </a:prstGeom>
+          <a:noFill/>
+          <a:ln/>
+        </p:spPr>
+        <p:txBody>
+          <a:bodyPr wrap="square" lIns="0" tIns="0" rIns="0" bIns="0" rtlCol="0" anchor="ctr"/>
+          <a:lstStyle/>
+          <a:p>
+            <a:pPr indent="0" marL="0">
+              <a:buNone/>
+            </a:pPr>
+            <a:r>
+              <a:rPr lang="en-US" sz="1600" dirty="0">
+                <a:solidFill>
+                  <a:srgbClr val="5C6F7B"/>
+                </a:solidFill>
+              </a:rPr>
+              <a:t>la correzione resta scritta e si può rifare</a:t>
+            </a:r>
+            <a:endParaRPr lang="en-US" sz="1600" dirty="0"/>
+          </a:p>
+        </p:txBody>
+      </p:sp>
+      <p:sp>
+        <p:nvSpPr>
+          <p:cNvPr id="14" name="Shape 12"/>
+          <p:cNvSpPr/>
+          <p:nvPr/>
+        </p:nvSpPr>
+        <p:spPr>
+          <a:xfrm>
+            <a:off x="6172200" y="4251960"/>
+            <a:ext cx="5440680" cy="1325880"/>
+          </a:xfrm>
+          <a:prstGeom prst="roundRect">
+            <a:avLst>
+              <a:gd name="adj" fmla="val 8276"/>
+            </a:avLst>
+          </a:prstGeom>
+          <a:solidFill>
+            <a:srgbClr val="EEF3F4"/>
+          </a:solidFill>
+          <a:ln/>
+        </p:spPr>
+      </p:sp>
+      <p:sp>
+        <p:nvSpPr>
+          <p:cNvPr id="15" name="Shape 13"/>
+          <p:cNvSpPr/>
+          <p:nvPr/>
+        </p:nvSpPr>
+        <p:spPr>
+          <a:xfrm>
+            <a:off x="6446520" y="4553712"/>
+            <a:ext cx="685800" cy="685800"/>
+          </a:xfrm>
+          <a:prstGeom prst="ellipse">
+            <a:avLst/>
+          </a:prstGeom>
+          <a:solidFill>
+            <a:srgbClr val="E09F3E"/>
+          </a:solidFill>
+          <a:ln/>
+        </p:spPr>
+      </p:sp>
+      <p:sp>
+        <p:nvSpPr>
+          <p:cNvPr id="16" name="Text 14"/>
+          <p:cNvSpPr txBox="1"/>
+          <p:nvPr/>
+        </p:nvSpPr>
+        <p:spPr>
+          <a:xfrm>
+            <a:off x="6446520" y="4553712"/>
+            <a:ext cx="685800" cy="685800"/>
+          </a:xfrm>
+          <a:prstGeom prst="rect">
+            <a:avLst/>
+          </a:prstGeom>
+          <a:noFill/>
+          <a:ln/>
+        </p:spPr>
+        <p:txBody>
+          <a:bodyPr wrap="square" lIns="0" tIns="0" rIns="0" bIns="0" rtlCol="0" anchor="ctr"/>
+          <a:lstStyle/>
+          <a:p>
+            <a:pPr algn="ctr" indent="0" marL="0">
+              <a:buNone/>
+            </a:pPr>
+            <a:r>
+              <a:rPr lang="en-US" sz="1950" b="1" dirty="0">
+                <a:solidFill>
+                  <a:srgbClr val="1F2A30"/>
+                </a:solidFill>
+              </a:rPr>
+              <a:t>2</a:t>
+            </a:r>
+            <a:endParaRPr lang="en-US" sz="1950" dirty="0"/>
+          </a:p>
+        </p:txBody>
+      </p:sp>
+      <p:sp>
+        <p:nvSpPr>
+          <p:cNvPr id="17" name="Text 15"/>
+          <p:cNvSpPr txBox="1"/>
+          <p:nvPr/>
+        </p:nvSpPr>
+        <p:spPr>
+          <a:xfrm>
+            <a:off x="7360920" y="4434840"/>
+            <a:ext cx="4069080" cy="457200"/>
+          </a:xfrm>
+          <a:prstGeom prst="rect">
+            <a:avLst/>
+          </a:prstGeom>
+          <a:noFill/>
+          <a:ln/>
+        </p:spPr>
+        <p:txBody>
+          <a:bodyPr wrap="square" lIns="0" tIns="0" rIns="0" bIns="0" rtlCol="0" anchor="ctr"/>
+          <a:lstStyle/>
+          <a:p>
+            <a:pPr indent="0" marL="0">
+              <a:buNone/>
+            </a:pPr>
+            <a:r>
+              <a:rPr lang="en-US" sz="2000" b="1" dirty="0">
+                <a:solidFill>
+                  <a:srgbClr val="1F2A30"/>
+                </a:solidFill>
+              </a:rPr>
+              <a:t>Per contenuto, non per numero di riga</a:t>
+            </a:r>
+            <a:endParaRPr lang="en-US" sz="2000" dirty="0"/>
+          </a:p>
+        </p:txBody>
+      </p:sp>
+      <p:sp>
+        <p:nvSpPr>
+          <p:cNvPr id="18" name="Text 16"/>
+          <p:cNvSpPr txBox="1"/>
+          <p:nvPr/>
+        </p:nvSpPr>
+        <p:spPr>
+          <a:xfrm>
+            <a:off x="7360920" y="4892040"/>
+            <a:ext cx="4069080" cy="502920"/>
+          </a:xfrm>
+          <a:prstGeom prst="rect">
+            <a:avLst/>
+          </a:prstGeom>
+          <a:noFill/>
+          <a:ln/>
+        </p:spPr>
+        <p:txBody>
+          <a:bodyPr wrap="square" lIns="0" tIns="0" rIns="0" bIns="0" rtlCol="0" anchor="ctr"/>
+          <a:lstStyle/>
+          <a:p>
+            <a:pPr indent="0" marL="0">
+              <a:buNone/>
+            </a:pPr>
+            <a:r>
+              <a:rPr lang="en-US" sz="1600" dirty="0">
+                <a:solidFill>
+                  <a:srgbClr val="5C6F7B"/>
+                </a:solidFill>
+              </a:rPr>
+              <a:t>dopo un ordinamento la riga 500 è un'altra</a:t>
+            </a:r>
+            <a:endParaRPr lang="en-US" sz="1600" dirty="0"/>
+          </a:p>
+        </p:txBody>
+      </p:sp>
+      <p:sp>
+        <p:nvSpPr>
+          <p:cNvPr id="19" name="Text 17"/>
+          <p:cNvSpPr txBox="1"/>
+          <p:nvPr/>
+        </p:nvSpPr>
+        <p:spPr>
+          <a:xfrm>
+            <a:off x="548640" y="5760720"/>
+            <a:ext cx="11064240" cy="411480"/>
+          </a:xfrm>
+          <a:prstGeom prst="rect">
+            <a:avLst/>
+          </a:prstGeom>
+          <a:noFill/>
+          <a:ln/>
+        </p:spPr>
+        <p:txBody>
+          <a:bodyPr wrap="square" lIns="0" tIns="0" rIns="0" bIns="0" rtlCol="0" anchor="ctr"/>
+          <a:lstStyle/>
+          <a:p>
+            <a:pPr indent="0" marL="0">
+              <a:buNone/>
+            </a:pPr>
+            <a:r>
+              <a:rPr lang="en-US" sz="1700" i="1" dirty="0">
+                <a:solidFill>
+                  <a:srgbClr val="0F4C5C"/>
+                </a:solidFill>
+              </a:rPr>
+              <a:t>Due condizioni insieme: &amp;, e ognuna tra parentesi.</a:t>
+            </a:r>
+            <a:endParaRPr lang="en-US" sz="1700" dirty="0"/>
+          </a:p>
+        </p:txBody>
+      </p:sp>
+      <p:sp>
+        <p:nvSpPr>
+          <p:cNvPr id="25" name="Slide Number Placeholder 0"/>
+          <p:cNvSpPr>
+            <a:spLocks noGrp="1"/>
+          </p:cNvSpPr>
           <p:nvPr>
-            <p:ph idx="101" type="body" hasCustomPrompt="1"/>
+            <p:ph type="sldNum" sz="quarter" idx="4294967295"/>
           </p:nvPr>
         </p:nvSpPr>
         <p:spPr>
           <a:xfrm>
-            <a:off x="731520" y="3657600"/>
-            <a:ext cx="10698480" cy="1463040"/>
-          </a:xfrm>
-          <a:prstGeom prst="rect">
-            <a:avLst/>
-          </a:prstGeom>
-          <a:noFill/>
-          <a:ln/>
-        </p:spPr>
-        <p:txBody>
-          <a:bodyPr wrap="square" lIns="0" tIns="0" rIns="0" bIns="0" rtlCol="0" anchor="t"/>
-          <a:lstStyle/>
-          <a:p>
-            <a:pPr indent="0" marL="0">
-              <a:buNone/>
-            </a:pPr>
-            <a:r>
-              <a:rPr lang="en-US" sz="2200" dirty="0">
-                <a:solidFill>
-                  <a:srgbClr val="B8C4CB"/>
-                </a:solidFill>
-              </a:rPr>
-              <a:t>Obiettivo: 2.500 righe, 20 regioni, un fatturato numerico e plausibile.</a:t>
-            </a:r>
-            <a:endParaRPr lang="en-US" sz="2200" dirty="0"/>
-          </a:p>
-          <a:p>
-            <a:pPr indent="0" marL="0">
-              <a:buNone/>
-            </a:pPr>
-            <a:r>
-              <a:rPr lang="en-US" sz="2200" dirty="0">
-                <a:solidFill>
-                  <a:srgbClr val="B8C4CB"/>
-                </a:solidFill>
-              </a:rPr>
-              <a:t>60 minuti · apri il notebook dal README</a:t>
-            </a:r>
-            <a:endParaRPr lang="en-US" sz="2200" dirty="0"/>
+            <a:off x="11155680" y="6400800"/>
+            <a:ext cx="457200" cy="274320"/>
+          </a:xfrm>
+          <a:prstGeom prst="rect">
+            <a:avLst/>
+          </a:prstGeom>
+          <a:extLst>
+            <a:ext uri="{C572A759-6A51-4108-AA02-DFA0A04FC94B}">
+              <ma14:wrappingTextBoxFlag xmlns:ma14="http://schemas.microsoft.com/office/mac/drawingml/2011/main" val="0"/>
+            </a:ext>
+          </a:extLst>
+        </p:spPr>
+        <p:txBody>
+          <a:bodyPr/>
+          <a:lstStyle>
+            <a:lvl1pPr>
+              <a:defRPr sz="1000">
+                <a:solidFill>
+                  <a:srgbClr val="5C6F7B"/>
+                </a:solidFill>
+              </a:defRPr>
+            </a:lvl1pPr>
+          </a:lstStyle>
+          <a:p>
+            <a:pPr algn="r"/>
+            <a:fld id="{F7021451-1387-4CA6-816F-3879F97B5CBC}" type="slidenum">
+              <a:rPr b="0" lang="en-US"/>
+              <a:t>9</a:t>
+            </a:fld>
+            <a:endParaRPr lang="en-US"/>
           </a:p>
         </p:txBody>
       </p:sp>

</xml_diff>